<commit_message>
feat(ppt): checkpoint deterministic export baseline
</commit_message>
<xml_diff>
--- a/assets/templates/PPT_Vorlage_Wuerth.pptx
+++ b/assets/templates/PPT_Vorlage_Wuerth.pptx
@@ -361,7 +361,7 @@
           <a:p>
             <a:fld id="{DC667BD7-7836-4542-96EC-FA1F2778C457}" type="datetimeFigureOut">
               <a:rPr lang="de-DE" smtClean="0"/>
-              <a:t>21.06.2026</a:t>
+              <a:t>22.06.2026</a:t>
             </a:fld>
             <a:endParaRPr lang="de-DE" dirty="0"/>
           </a:p>
@@ -554,7 +554,7 @@
           <a:p>
             <a:fld id="{80F21216-8C03-4DD3-BCF1-B03CA63F3592}" type="datetimeFigureOut">
               <a:rPr lang="de-DE" smtClean="0"/>
-              <a:t>21.06.2026</a:t>
+              <a:t>22.06.2026</a:t>
             </a:fld>
             <a:endParaRPr lang="de-DE" dirty="0"/>
           </a:p>
@@ -909,7 +909,7 @@
 
 <file path=ppt/slideLayouts/slideLayout1.xml><?xml version="1.0" encoding="utf-8"?>
 <p:sldLayout xmlns:a="http://schemas.openxmlformats.org/drawingml/2006/main" xmlns:r="http://schemas.openxmlformats.org/officeDocument/2006/relationships" xmlns:p="http://schemas.openxmlformats.org/presentationml/2006/main" showMasterSp="0" preserve="1" userDrawn="1">
-  <p:cSld name="Agent 01 Cover">
+  <p:cSld name="agent_01_cover">
     <p:spTree>
       <p:nvGrpSpPr>
         <p:cNvPr id="1" name=""/>
@@ -924,9 +924,81 @@
           <a:chExt cx="0" cy="0"/>
         </a:xfrm>
       </p:grpSpPr>
-      <p:sp>
-        <p:nvSpPr>
-          <p:cNvPr id="8" name="Rechteck 7">
+      <p:graphicFrame>
+        <p:nvGraphicFramePr>
+          <p:cNvPr id="9" name="think-cell data - do not delete" hidden="1">
+            <a:extLst>
+              <a:ext uri="{FF2B5EF4-FFF2-40B4-BE49-F238E27FC236}">
+                <a16:creationId xmlns:a16="http://schemas.microsoft.com/office/drawing/2014/main" id="{AEE72942-81F5-3F86-AC0E-350546FB8B6E}"/>
+              </a:ext>
+            </a:extLst>
+          </p:cNvPr>
+          <p:cNvGraphicFramePr>
+            <a:graphicFrameLocks/>
+          </p:cNvGraphicFramePr>
+          <p:nvPr>
+            <p:custDataLst>
+              <p:tags r:id="rId1"/>
+            </p:custDataLst>
+            <p:extLst>
+              <p:ext uri="{D42A27DB-BD31-4B8C-83A1-F6EECF244321}">
+                <p14:modId xmlns:p14="http://schemas.microsoft.com/office/powerpoint/2010/main" val="4165350210"/>
+              </p:ext>
+            </p:extLst>
+          </p:nvPr>
+        </p:nvGraphicFramePr>
+        <p:xfrm>
+          <a:off x="1588" y="1588"/>
+          <a:ext cx="1588" cy="1588"/>
+        </p:xfrm>
+        <a:graphic>
+          <a:graphicData uri="http://schemas.openxmlformats.org/presentationml/2006/ole">
+            <mc:AlternateContent xmlns:mc="http://schemas.openxmlformats.org/markup-compatibility/2006">
+              <mc:Choice xmlns:v="urn:schemas-microsoft-com:vml" Requires="v">
+                <p:oleObj name="think-cell Slide" r:id="rId3" imgW="346" imgH="340" progId="TCLayout.ActiveDocument.1">
+                  <p:embed/>
+                </p:oleObj>
+              </mc:Choice>
+              <mc:Fallback>
+                <p:oleObj name="think-cell Slide" r:id="rId3" imgW="346" imgH="340" progId="TCLayout.ActiveDocument.1">
+                  <p:embed/>
+                  <p:pic>
+                    <p:nvPicPr>
+                      <p:cNvPr id="9" name="think-cell data - do not delete" hidden="1">
+                        <a:extLst>
+                          <a:ext uri="{FF2B5EF4-FFF2-40B4-BE49-F238E27FC236}">
+                            <a16:creationId xmlns:a16="http://schemas.microsoft.com/office/drawing/2014/main" id="{AEE72942-81F5-3F86-AC0E-350546FB8B6E}"/>
+                          </a:ext>
+                        </a:extLst>
+                      </p:cNvPr>
+                      <p:cNvPicPr/>
+                      <p:nvPr/>
+                    </p:nvPicPr>
+                    <p:blipFill>
+                      <a:blip r:embed="rId4"/>
+                      <a:stretch>
+                        <a:fillRect/>
+                      </a:stretch>
+                    </p:blipFill>
+                    <p:spPr>
+                      <a:xfrm>
+                        <a:off x="1588" y="1588"/>
+                        <a:ext cx="1588" cy="1588"/>
+                      </a:xfrm>
+                      <a:prstGeom prst="rect">
+                        <a:avLst/>
+                      </a:prstGeom>
+                    </p:spPr>
+                  </p:pic>
+                </p:oleObj>
+              </mc:Fallback>
+            </mc:AlternateContent>
+          </a:graphicData>
+        </a:graphic>
+      </p:graphicFrame>
+      <p:sp>
+        <p:nvSpPr>
+          <p:cNvPr id="8" name="bg_red">
             <a:extLst>
               <a:ext uri="{FF2B5EF4-FFF2-40B4-BE49-F238E27FC236}">
                 <a16:creationId xmlns:a16="http://schemas.microsoft.com/office/drawing/2014/main" id="{D05A5A43-4123-1C03-5F5B-912DCD54F08F}"/>
@@ -980,158 +1052,93 @@
           </a:p>
         </p:txBody>
       </p:sp>
-      <p:pic>
-        <p:nvPicPr>
-          <p:cNvPr id="7" name="Grafik 6" descr="Ein Bild, das Logo enthält.&#10;&#10;Automatisch generierte Beschreibung">
-            <a:extLst>
-              <a:ext uri="{FF2B5EF4-FFF2-40B4-BE49-F238E27FC236}">
-                <a16:creationId xmlns:a16="http://schemas.microsoft.com/office/drawing/2014/main" id="{B8B6A5F9-03AE-A705-0F9D-FC577BDDF3D1}"/>
-              </a:ext>
-            </a:extLst>
-          </p:cNvPr>
-          <p:cNvPicPr>
-            <a:picLocks noChangeAspect="1"/>
-          </p:cNvPicPr>
-          <p:nvPr/>
-        </p:nvPicPr>
-        <p:blipFill rotWithShape="1">
-          <a:blip r:embed="rId3">
-            <a:alphaModFix/>
-          </a:blip>
-          <a:srcRect b="798"/>
-          <a:stretch/>
-        </p:blipFill>
+      <p:sp>
+        <p:nvSpPr>
+          <p:cNvPr id="4" name="footer_date">
+            <a:extLst>
+              <a:ext uri="{FF2B5EF4-FFF2-40B4-BE49-F238E27FC236}">
+                <a16:creationId xmlns:a16="http://schemas.microsoft.com/office/drawing/2014/main" id="{60FA290F-70BD-69E1-FC16-482DFCA768DD}"/>
+              </a:ext>
+            </a:extLst>
+          </p:cNvPr>
+          <p:cNvSpPr>
+            <a:spLocks noGrp="1"/>
+          </p:cNvSpPr>
+          <p:nvPr>
+            <p:ph type="body" sz="quarter" idx="15" hasCustomPrompt="1"/>
+          </p:nvPr>
+        </p:nvSpPr>
         <p:spPr bwMode="gray">
           <a:xfrm>
-            <a:off x="365124" y="338138"/>
-            <a:ext cx="2664000" cy="969961"/>
+            <a:off x="1634864" y="4283522"/>
+            <a:ext cx="1146212" cy="311327"/>
           </a:xfrm>
-          <a:prstGeom prst="rect">
-            <a:avLst/>
-          </a:prstGeom>
         </p:spPr>
-      </p:pic>
-      <p:graphicFrame>
-        <p:nvGraphicFramePr>
-          <p:cNvPr id="9" name="think-cell data - do not delete" hidden="1">
-            <a:extLst>
-              <a:ext uri="{FF2B5EF4-FFF2-40B4-BE49-F238E27FC236}">
-                <a16:creationId xmlns:a16="http://schemas.microsoft.com/office/drawing/2014/main" id="{AEE72942-81F5-3F86-AC0E-350546FB8B6E}"/>
-              </a:ext>
-            </a:extLst>
-          </p:cNvPr>
-          <p:cNvGraphicFramePr>
-            <a:graphicFrameLocks/>
-          </p:cNvGraphicFramePr>
-          <p:nvPr>
-            <p:custDataLst>
-              <p:tags r:id="rId1"/>
-            </p:custDataLst>
-            <p:extLst>
-              <p:ext uri="{D42A27DB-BD31-4B8C-83A1-F6EECF244321}">
-                <p14:modId xmlns:p14="http://schemas.microsoft.com/office/powerpoint/2010/main" val="3985669279"/>
-              </p:ext>
-            </p:extLst>
-          </p:nvPr>
-        </p:nvGraphicFramePr>
-        <p:xfrm>
-          <a:off x="1588" y="1588"/>
-          <a:ext cx="1588" cy="1588"/>
-        </p:xfrm>
-        <a:graphic>
-          <a:graphicData uri="http://schemas.openxmlformats.org/presentationml/2006/ole">
-            <mc:AlternateContent xmlns:mc="http://schemas.openxmlformats.org/markup-compatibility/2006">
-              <mc:Choice xmlns:v="urn:schemas-microsoft-com:vml" Requires="v">
-                <p:oleObj name="think-cell Slide" r:id="rId4" imgW="346" imgH="340" progId="TCLayout.ActiveDocument.1">
-                  <p:embed/>
-                </p:oleObj>
-              </mc:Choice>
-              <mc:Fallback>
-                <p:oleObj name="think-cell Slide" r:id="rId4" imgW="346" imgH="340" progId="TCLayout.ActiveDocument.1">
-                  <p:embed/>
-                  <p:pic>
-                    <p:nvPicPr>
-                      <p:cNvPr id="9" name="think-cell data - do not delete" hidden="1">
-                        <a:extLst>
-                          <a:ext uri="{FF2B5EF4-FFF2-40B4-BE49-F238E27FC236}">
-                            <a16:creationId xmlns:a16="http://schemas.microsoft.com/office/drawing/2014/main" id="{AEE72942-81F5-3F86-AC0E-350546FB8B6E}"/>
-                          </a:ext>
-                        </a:extLst>
-                      </p:cNvPr>
-                      <p:cNvPicPr/>
-                      <p:nvPr/>
-                    </p:nvPicPr>
-                    <p:blipFill>
-                      <a:blip r:embed="rId5"/>
-                      <a:stretch>
-                        <a:fillRect/>
-                      </a:stretch>
-                    </p:blipFill>
-                    <p:spPr>
-                      <a:xfrm>
-                        <a:off x="1588" y="1588"/>
-                        <a:ext cx="1588" cy="1588"/>
-                      </a:xfrm>
-                      <a:prstGeom prst="rect">
-                        <a:avLst/>
-                      </a:prstGeom>
-                    </p:spPr>
-                  </p:pic>
-                </p:oleObj>
-              </mc:Fallback>
-            </mc:AlternateContent>
-          </a:graphicData>
-        </a:graphic>
-      </p:graphicFrame>
-      <p:sp>
-        <p:nvSpPr>
-          <p:cNvPr id="2" name="Titel 1">
-            <a:extLst>
-              <a:ext uri="{FF2B5EF4-FFF2-40B4-BE49-F238E27FC236}">
-                <a16:creationId xmlns:a16="http://schemas.microsoft.com/office/drawing/2014/main" id="{3C0783DB-C9E2-637D-90E1-483141D0C3A0}"/>
-              </a:ext>
-            </a:extLst>
-          </p:cNvPr>
-          <p:cNvSpPr>
-            <a:spLocks noGrp="1"/>
-          </p:cNvSpPr>
-          <p:nvPr>
-            <p:ph type="ctrTitle"/>
-          </p:nvPr>
-        </p:nvSpPr>
-        <p:spPr bwMode="gray">
-          <a:xfrm>
-            <a:off x="365124" y="1492678"/>
-            <a:ext cx="8413749" cy="2132336"/>
-          </a:xfrm>
-          <a:noFill/>
-        </p:spPr>
-        <p:txBody>
-          <a:bodyPr vert="horz" lIns="0" tIns="0" rIns="0" bIns="0" anchor="t"/>
+        <p:txBody>
+          <a:bodyPr lIns="0" anchor="t"/>
           <a:lstStyle>
-            <a:lvl1pPr algn="l">
-              <a:lnSpc>
-                <a:spcPct val="80000"/>
-              </a:lnSpc>
-              <a:defRPr sz="5700">
+            <a:lvl1pPr>
+              <a:defRPr sz="1600">
                 <a:solidFill>
                   <a:schemeClr val="bg1"/>
                 </a:solidFill>
-                <a:latin typeface="Wuerth Extra Bold Cond Caps" pitchFamily="2" charset="0"/>
               </a:defRPr>
             </a:lvl1pPr>
           </a:lstStyle>
           <a:p>
-            <a:r>
-              <a:rPr lang="de-DE" dirty="0"/>
-              <a:t>Mastertitelformat bearbeiten</a:t>
-            </a:r>
-          </a:p>
-        </p:txBody>
-      </p:sp>
-      <p:sp>
-        <p:nvSpPr>
-          <p:cNvPr id="3" name="Untertitel 2">
+            <a:pPr lvl="0"/>
+            <a:r>
+              <a:rPr lang="de-DE" dirty="0"/>
+              <a:t>Datum</a:t>
+            </a:r>
+          </a:p>
+        </p:txBody>
+      </p:sp>
+      <p:sp>
+        <p:nvSpPr>
+          <p:cNvPr id="14" name="footer_author">
+            <a:extLst>
+              <a:ext uri="{FF2B5EF4-FFF2-40B4-BE49-F238E27FC236}">
+                <a16:creationId xmlns:a16="http://schemas.microsoft.com/office/drawing/2014/main" id="{D04C3FA1-306F-D949-4B06-75F240049E42}"/>
+              </a:ext>
+            </a:extLst>
+          </p:cNvPr>
+          <p:cNvSpPr>
+            <a:spLocks noGrp="1"/>
+          </p:cNvSpPr>
+          <p:nvPr>
+            <p:ph type="body" sz="quarter" idx="14" hasCustomPrompt="1"/>
+          </p:nvPr>
+        </p:nvSpPr>
+        <p:spPr bwMode="gray">
+          <a:xfrm>
+            <a:off x="365127" y="4283522"/>
+            <a:ext cx="1207832" cy="311327"/>
+          </a:xfrm>
+        </p:spPr>
+        <p:txBody>
+          <a:bodyPr lIns="0" anchor="t"/>
+          <a:lstStyle>
+            <a:lvl1pPr>
+              <a:defRPr sz="1600">
+                <a:solidFill>
+                  <a:schemeClr val="bg1"/>
+                </a:solidFill>
+              </a:defRPr>
+            </a:lvl1pPr>
+          </a:lstStyle>
+          <a:p>
+            <a:pPr lvl="0"/>
+            <a:r>
+              <a:rPr lang="de-DE" dirty="0"/>
+              <a:t>Autor</a:t>
+            </a:r>
+          </a:p>
+        </p:txBody>
+      </p:sp>
+      <p:sp>
+        <p:nvSpPr>
+          <p:cNvPr id="3" name="subtitle">
             <a:extLst>
               <a:ext uri="{FF2B5EF4-FFF2-40B4-BE49-F238E27FC236}">
                 <a16:creationId xmlns:a16="http://schemas.microsoft.com/office/drawing/2014/main" id="{6C16939D-D1CD-ADD5-A474-6A1406439571}"/>
@@ -1142,7 +1149,7 @@
             <a:spLocks noGrp="1"/>
           </p:cNvSpPr>
           <p:nvPr>
-            <p:ph type="subTitle" idx="1"/>
+            <p:ph type="subTitle" idx="1" hasCustomPrompt="1"/>
           </p:nvPr>
         </p:nvSpPr>
         <p:spPr bwMode="gray">
@@ -1214,46 +1221,88 @@
       </p:sp>
       <p:sp>
         <p:nvSpPr>
-          <p:cNvPr id="14" name="Textplatzhalter 21">
-            <a:extLst>
-              <a:ext uri="{FF2B5EF4-FFF2-40B4-BE49-F238E27FC236}">
-                <a16:creationId xmlns:a16="http://schemas.microsoft.com/office/drawing/2014/main" id="{D04C3FA1-306F-D949-4B06-75F240049E42}"/>
-              </a:ext>
-            </a:extLst>
-          </p:cNvPr>
-          <p:cNvSpPr>
-            <a:spLocks noGrp="1"/>
-          </p:cNvSpPr>
-          <p:nvPr>
-            <p:ph type="body" sz="quarter" idx="14" hasCustomPrompt="1"/>
+          <p:cNvPr id="2" name="title">
+            <a:extLst>
+              <a:ext uri="{FF2B5EF4-FFF2-40B4-BE49-F238E27FC236}">
+                <a16:creationId xmlns:a16="http://schemas.microsoft.com/office/drawing/2014/main" id="{3C0783DB-C9E2-637D-90E1-483141D0C3A0}"/>
+              </a:ext>
+            </a:extLst>
+          </p:cNvPr>
+          <p:cNvSpPr>
+            <a:spLocks noGrp="1"/>
+          </p:cNvSpPr>
+          <p:nvPr>
+            <p:ph type="ctrTitle" hasCustomPrompt="1"/>
           </p:nvPr>
         </p:nvSpPr>
         <p:spPr bwMode="gray">
           <a:xfrm>
-            <a:off x="365126" y="4254026"/>
-            <a:ext cx="6786063" cy="311327"/>
+            <a:off x="365124" y="1492678"/>
+            <a:ext cx="8413749" cy="2132336"/>
           </a:xfrm>
+          <a:noFill/>
         </p:spPr>
         <p:txBody>
-          <a:bodyPr lIns="0" anchor="t"/>
+          <a:bodyPr vert="horz" lIns="0" tIns="0" rIns="0" bIns="0" anchor="t"/>
           <a:lstStyle>
-            <a:lvl1pPr>
-              <a:defRPr sz="1600">
+            <a:lvl1pPr algn="l">
+              <a:lnSpc>
+                <a:spcPct val="80000"/>
+              </a:lnSpc>
+              <a:defRPr sz="5700">
                 <a:solidFill>
                   <a:schemeClr val="bg1"/>
                 </a:solidFill>
+                <a:latin typeface="Wuerth Extra Bold Cond Caps" pitchFamily="2" charset="0"/>
               </a:defRPr>
             </a:lvl1pPr>
           </a:lstStyle>
           <a:p>
-            <a:pPr lvl="0"/>
-            <a:r>
-              <a:rPr lang="de-DE" dirty="0"/>
-              <a:t>Autor | Datum</a:t>
-            </a:r>
-          </a:p>
-        </p:txBody>
-      </p:sp>
+            <a:r>
+              <a:rPr lang="de-DE" dirty="0"/>
+              <a:t>Mastertitelformat</a:t>
+            </a:r>
+            <a:br>
+              <a:rPr lang="de-DE" dirty="0"/>
+            </a:br>
+            <a:r>
+              <a:rPr lang="de-DE" dirty="0"/>
+              <a:t>Bearbeiten</a:t>
+            </a:r>
+          </a:p>
+        </p:txBody>
+      </p:sp>
+      <p:pic>
+        <p:nvPicPr>
+          <p:cNvPr id="7" name="brand_logo" descr="Ein Bild, das Logo enthält.&#10;&#10;Automatisch generierte Beschreibung">
+            <a:extLst>
+              <a:ext uri="{FF2B5EF4-FFF2-40B4-BE49-F238E27FC236}">
+                <a16:creationId xmlns:a16="http://schemas.microsoft.com/office/drawing/2014/main" id="{B8B6A5F9-03AE-A705-0F9D-FC577BDDF3D1}"/>
+              </a:ext>
+            </a:extLst>
+          </p:cNvPr>
+          <p:cNvPicPr>
+            <a:picLocks noChangeAspect="1"/>
+          </p:cNvPicPr>
+          <p:nvPr/>
+        </p:nvPicPr>
+        <p:blipFill rotWithShape="1">
+          <a:blip r:embed="rId5">
+            <a:alphaModFix/>
+          </a:blip>
+          <a:srcRect b="798"/>
+          <a:stretch/>
+        </p:blipFill>
+        <p:spPr bwMode="gray">
+          <a:xfrm>
+            <a:off x="365124" y="338138"/>
+            <a:ext cx="2664000" cy="969961"/>
+          </a:xfrm>
+          <a:prstGeom prst="rect">
+            <a:avLst/>
+          </a:prstGeom>
+        </p:spPr>
+      </p:pic>
     </p:spTree>
     <p:extLst>
       <p:ext uri="{BB962C8B-B14F-4D97-AF65-F5344CB8AC3E}">
@@ -1274,7 +1323,7 @@
 
 <file path=ppt/slideLayouts/slideLayout2.xml><?xml version="1.0" encoding="utf-8"?>
 <p:sldLayout xmlns:a="http://schemas.openxmlformats.org/drawingml/2006/main" xmlns:r="http://schemas.openxmlformats.org/officeDocument/2006/relationships" xmlns:p="http://schemas.openxmlformats.org/presentationml/2006/main" preserve="1" userDrawn="1">
-  <p:cSld name="Agent 02 Executive Summary">
+  <p:cSld name="agent_02_summary">
     <p:spTree>
       <p:nvGrpSpPr>
         <p:cNvPr id="1" name=""/>
@@ -1307,7 +1356,7 @@
             </p:custDataLst>
             <p:extLst>
               <p:ext uri="{D42A27DB-BD31-4B8C-83A1-F6EECF244321}">
-                <p14:modId xmlns:p14="http://schemas.microsoft.com/office/powerpoint/2010/main" val="2848507216"/>
+                <p14:modId xmlns:p14="http://schemas.microsoft.com/office/powerpoint/2010/main" val="3376174090"/>
               </p:ext>
             </p:extLst>
           </p:nvPr>
@@ -1363,7 +1412,96 @@
       </p:graphicFrame>
       <p:sp>
         <p:nvSpPr>
-          <p:cNvPr id="27" name="Inhaltsplatzhalter 26">
+          <p:cNvPr id="4" name="footer_date">
+            <a:extLst>
+              <a:ext uri="{FF2B5EF4-FFF2-40B4-BE49-F238E27FC236}">
+                <a16:creationId xmlns:a16="http://schemas.microsoft.com/office/drawing/2014/main" id="{4091CEBF-0315-0376-AECC-72B522000048}"/>
+              </a:ext>
+            </a:extLst>
+          </p:cNvPr>
+          <p:cNvSpPr>
+            <a:spLocks noGrp="1"/>
+          </p:cNvSpPr>
+          <p:nvPr>
+            <p:ph type="dt" sz="half" idx="15"/>
+          </p:nvPr>
+        </p:nvSpPr>
+        <p:spPr/>
+        <p:txBody>
+          <a:bodyPr/>
+          <a:lstStyle/>
+          <a:p>
+            <a:pPr indent="-468000"/>
+            <a:fld id="{84284A58-3EB3-4F57-9112-3DEC02019146}" type="datetime1">
+              <a:rPr lang="de-DE" smtClean="0"/>
+              <a:t>22.06.2026</a:t>
+            </a:fld>
+            <a:endParaRPr lang="de-DE" dirty="0"/>
+          </a:p>
+        </p:txBody>
+      </p:sp>
+      <p:sp>
+        <p:nvSpPr>
+          <p:cNvPr id="6" name="footer_source">
+            <a:extLst>
+              <a:ext uri="{FF2B5EF4-FFF2-40B4-BE49-F238E27FC236}">
+                <a16:creationId xmlns:a16="http://schemas.microsoft.com/office/drawing/2014/main" id="{444FF8FF-43AA-977F-26BD-15CCF4FAB847}"/>
+              </a:ext>
+            </a:extLst>
+          </p:cNvPr>
+          <p:cNvSpPr>
+            <a:spLocks noGrp="1"/>
+          </p:cNvSpPr>
+          <p:nvPr>
+            <p:ph type="ftr" sz="quarter" idx="16"/>
+          </p:nvPr>
+        </p:nvSpPr>
+        <p:spPr/>
+        <p:txBody>
+          <a:bodyPr/>
+          <a:lstStyle/>
+          <a:p>
+            <a:pPr indent="-468000"/>
+            <a:r>
+              <a:rPr lang="de-DE" dirty="0"/>
+              <a:t>Würth Line Folienmaster</a:t>
+            </a:r>
+          </a:p>
+        </p:txBody>
+      </p:sp>
+      <p:sp>
+        <p:nvSpPr>
+          <p:cNvPr id="8" name="footer_slide_number">
+            <a:extLst>
+              <a:ext uri="{FF2B5EF4-FFF2-40B4-BE49-F238E27FC236}">
+                <a16:creationId xmlns:a16="http://schemas.microsoft.com/office/drawing/2014/main" id="{6D9836F3-62A2-3351-A51F-696852650367}"/>
+              </a:ext>
+            </a:extLst>
+          </p:cNvPr>
+          <p:cNvSpPr>
+            <a:spLocks noGrp="1"/>
+          </p:cNvSpPr>
+          <p:nvPr>
+            <p:ph type="sldNum" sz="quarter" idx="17"/>
+          </p:nvPr>
+        </p:nvSpPr>
+        <p:spPr/>
+        <p:txBody>
+          <a:bodyPr/>
+          <a:lstStyle/>
+          <a:p>
+            <a:fld id="{3CBD43C5-A65B-4791-8A9A-EB6408C246D1}" type="slidenum">
+              <a:rPr lang="de-DE" smtClean="0"/>
+              <a:pPr/>
+              <a:t>‹#›</a:t>
+            </a:fld>
+            <a:endParaRPr lang="de-DE" dirty="0"/>
+          </a:p>
+        </p:txBody>
+      </p:sp>
+      <p:sp>
+        <p:nvSpPr>
+          <p:cNvPr id="27" name="body">
             <a:extLst>
               <a:ext uri="{FF2B5EF4-FFF2-40B4-BE49-F238E27FC236}">
                 <a16:creationId xmlns:a16="http://schemas.microsoft.com/office/drawing/2014/main" id="{7D331E16-2D08-849C-B297-29B2C68773C5}"/>
@@ -1435,7 +1573,7 @@
       </p:sp>
       <p:sp>
         <p:nvSpPr>
-          <p:cNvPr id="12" name="Textplatzhalter 11">
+          <p:cNvPr id="12" name="section_label">
             <a:extLst>
               <a:ext uri="{FF2B5EF4-FFF2-40B4-BE49-F238E27FC236}">
                 <a16:creationId xmlns:a16="http://schemas.microsoft.com/office/drawing/2014/main" id="{E4BB559A-959F-E065-EED1-B99203950C30}"/>
@@ -1550,7 +1688,7 @@
       </p:sp>
       <p:sp>
         <p:nvSpPr>
-          <p:cNvPr id="16" name="Titel 15">
+          <p:cNvPr id="16" name="title">
             <a:extLst>
               <a:ext uri="{FF2B5EF4-FFF2-40B4-BE49-F238E27FC236}">
                 <a16:creationId xmlns:a16="http://schemas.microsoft.com/office/drawing/2014/main" id="{B6DFC255-7930-5C81-0D87-2A24C89824D6}"/>
@@ -1561,107 +1699,18 @@
             <a:spLocks noGrp="1"/>
           </p:cNvSpPr>
           <p:nvPr>
-            <p:ph type="title"/>
+            <p:ph type="title" hasCustomPrompt="1"/>
           </p:nvPr>
         </p:nvSpPr>
         <p:spPr bwMode="gray"/>
         <p:txBody>
-          <a:bodyPr vert="horz"/>
+          <a:bodyPr vert="horz" rIns="0"/>
           <a:lstStyle/>
           <a:p>
             <a:r>
               <a:rPr lang="de-DE" dirty="0"/>
               <a:t>Mastertitelformat bearbeiten</a:t>
             </a:r>
-          </a:p>
-        </p:txBody>
-      </p:sp>
-      <p:sp>
-        <p:nvSpPr>
-          <p:cNvPr id="4" name="Datumsplatzhalter 3">
-            <a:extLst>
-              <a:ext uri="{FF2B5EF4-FFF2-40B4-BE49-F238E27FC236}">
-                <a16:creationId xmlns:a16="http://schemas.microsoft.com/office/drawing/2014/main" id="{4091CEBF-0315-0376-AECC-72B522000048}"/>
-              </a:ext>
-            </a:extLst>
-          </p:cNvPr>
-          <p:cNvSpPr>
-            <a:spLocks noGrp="1"/>
-          </p:cNvSpPr>
-          <p:nvPr>
-            <p:ph type="dt" sz="half" idx="15"/>
-          </p:nvPr>
-        </p:nvSpPr>
-        <p:spPr/>
-        <p:txBody>
-          <a:bodyPr/>
-          <a:lstStyle/>
-          <a:p>
-            <a:pPr indent="-468000"/>
-            <a:fld id="{84284A58-3EB3-4F57-9112-3DEC02019146}" type="datetime1">
-              <a:rPr lang="de-DE" smtClean="0"/>
-              <a:t>21.06.2026</a:t>
-            </a:fld>
-            <a:endParaRPr lang="de-DE" dirty="0"/>
-          </a:p>
-        </p:txBody>
-      </p:sp>
-      <p:sp>
-        <p:nvSpPr>
-          <p:cNvPr id="6" name="Fußzeilenplatzhalter 5">
-            <a:extLst>
-              <a:ext uri="{FF2B5EF4-FFF2-40B4-BE49-F238E27FC236}">
-                <a16:creationId xmlns:a16="http://schemas.microsoft.com/office/drawing/2014/main" id="{444FF8FF-43AA-977F-26BD-15CCF4FAB847}"/>
-              </a:ext>
-            </a:extLst>
-          </p:cNvPr>
-          <p:cNvSpPr>
-            <a:spLocks noGrp="1"/>
-          </p:cNvSpPr>
-          <p:nvPr>
-            <p:ph type="ftr" sz="quarter" idx="16"/>
-          </p:nvPr>
-        </p:nvSpPr>
-        <p:spPr/>
-        <p:txBody>
-          <a:bodyPr/>
-          <a:lstStyle/>
-          <a:p>
-            <a:pPr indent="-468000"/>
-            <a:r>
-              <a:rPr lang="de-DE" dirty="0"/>
-              <a:t>Würth Line Folienmaster</a:t>
-            </a:r>
-          </a:p>
-        </p:txBody>
-      </p:sp>
-      <p:sp>
-        <p:nvSpPr>
-          <p:cNvPr id="8" name="Foliennummernplatzhalter 7">
-            <a:extLst>
-              <a:ext uri="{FF2B5EF4-FFF2-40B4-BE49-F238E27FC236}">
-                <a16:creationId xmlns:a16="http://schemas.microsoft.com/office/drawing/2014/main" id="{6D9836F3-62A2-3351-A51F-696852650367}"/>
-              </a:ext>
-            </a:extLst>
-          </p:cNvPr>
-          <p:cNvSpPr>
-            <a:spLocks noGrp="1"/>
-          </p:cNvSpPr>
-          <p:nvPr>
-            <p:ph type="sldNum" sz="quarter" idx="17"/>
-          </p:nvPr>
-        </p:nvSpPr>
-        <p:spPr/>
-        <p:txBody>
-          <a:bodyPr/>
-          <a:lstStyle/>
-          <a:p>
-            <a:fld id="{3CBD43C5-A65B-4791-8A9A-EB6408C246D1}" type="slidenum">
-              <a:rPr lang="de-DE" smtClean="0"/>
-              <a:pPr/>
-              <a:t>‹#›</a:t>
-            </a:fld>
-            <a:endParaRPr lang="de-DE" dirty="0"/>
           </a:p>
         </p:txBody>
       </p:sp>
@@ -1685,7 +1734,7 @@
 
 <file path=ppt/slideLayouts/slideLayout3.xml><?xml version="1.0" encoding="utf-8"?>
 <p:sldLayout xmlns:a="http://schemas.openxmlformats.org/drawingml/2006/main" xmlns:r="http://schemas.openxmlformats.org/officeDocument/2006/relationships" xmlns:p="http://schemas.openxmlformats.org/presentationml/2006/main" preserve="1" userDrawn="1">
-  <p:cSld name="Agent 03 KPI Overview">
+  <p:cSld name="agent_03_three_cards">
     <p:spTree>
       <p:nvGrpSpPr>
         <p:cNvPr id="1" name=""/>
@@ -1774,7 +1823,449 @@
       </p:graphicFrame>
       <p:sp>
         <p:nvSpPr>
-          <p:cNvPr id="10" name="Textplatzhalter 11">
+          <p:cNvPr id="4" name="footer_date">
+            <a:extLst>
+              <a:ext uri="{FF2B5EF4-FFF2-40B4-BE49-F238E27FC236}">
+                <a16:creationId xmlns:a16="http://schemas.microsoft.com/office/drawing/2014/main" id="{207DB444-F5E1-C978-374D-AC897C8F71DD}"/>
+              </a:ext>
+            </a:extLst>
+          </p:cNvPr>
+          <p:cNvSpPr>
+            <a:spLocks noGrp="1"/>
+          </p:cNvSpPr>
+          <p:nvPr>
+            <p:ph type="dt" sz="half" idx="48"/>
+          </p:nvPr>
+        </p:nvSpPr>
+        <p:spPr/>
+        <p:txBody>
+          <a:bodyPr/>
+          <a:lstStyle/>
+          <a:p>
+            <a:pPr indent="-468000"/>
+            <a:fld id="{84284A58-3EB3-4F57-9112-3DEC02019146}" type="datetime1">
+              <a:rPr lang="de-DE" smtClean="0"/>
+              <a:t>22.06.2026</a:t>
+            </a:fld>
+            <a:endParaRPr lang="de-DE" dirty="0"/>
+          </a:p>
+        </p:txBody>
+      </p:sp>
+      <p:sp>
+        <p:nvSpPr>
+          <p:cNvPr id="6" name="footer_source">
+            <a:extLst>
+              <a:ext uri="{FF2B5EF4-FFF2-40B4-BE49-F238E27FC236}">
+                <a16:creationId xmlns:a16="http://schemas.microsoft.com/office/drawing/2014/main" id="{2A990709-5D8D-EA81-4798-B6BF38043537}"/>
+              </a:ext>
+            </a:extLst>
+          </p:cNvPr>
+          <p:cNvSpPr>
+            <a:spLocks noGrp="1"/>
+          </p:cNvSpPr>
+          <p:nvPr>
+            <p:ph type="ftr" sz="quarter" idx="49"/>
+          </p:nvPr>
+        </p:nvSpPr>
+        <p:spPr/>
+        <p:txBody>
+          <a:bodyPr/>
+          <a:lstStyle/>
+          <a:p>
+            <a:pPr indent="-468000"/>
+            <a:r>
+              <a:rPr lang="de-DE" dirty="0"/>
+              <a:t>Würth Line Folienmaster</a:t>
+            </a:r>
+          </a:p>
+        </p:txBody>
+      </p:sp>
+      <p:sp>
+        <p:nvSpPr>
+          <p:cNvPr id="7" name="footer_slide_number">
+            <a:extLst>
+              <a:ext uri="{FF2B5EF4-FFF2-40B4-BE49-F238E27FC236}">
+                <a16:creationId xmlns:a16="http://schemas.microsoft.com/office/drawing/2014/main" id="{FC516280-B4E8-8716-E5BF-5BD12DC9E791}"/>
+              </a:ext>
+            </a:extLst>
+          </p:cNvPr>
+          <p:cNvSpPr>
+            <a:spLocks noGrp="1"/>
+          </p:cNvSpPr>
+          <p:nvPr>
+            <p:ph type="sldNum" sz="quarter" idx="50"/>
+          </p:nvPr>
+        </p:nvSpPr>
+        <p:spPr>
+          <a:xfrm>
+            <a:off x="358775" y="4935051"/>
+            <a:ext cx="204257" cy="107722"/>
+          </a:xfrm>
+        </p:spPr>
+        <p:txBody>
+          <a:bodyPr/>
+          <a:lstStyle/>
+          <a:p>
+            <a:fld id="{3CBD43C5-A65B-4791-8A9A-EB6408C246D1}" type="slidenum">
+              <a:rPr lang="de-DE" smtClean="0"/>
+              <a:pPr/>
+              <a:t>‹#›</a:t>
+            </a:fld>
+            <a:endParaRPr lang="de-DE" dirty="0"/>
+          </a:p>
+        </p:txBody>
+      </p:sp>
+      <p:sp>
+        <p:nvSpPr>
+          <p:cNvPr id="30" name="card_3_body">
+            <a:extLst>
+              <a:ext uri="{FF2B5EF4-FFF2-40B4-BE49-F238E27FC236}">
+                <a16:creationId xmlns:a16="http://schemas.microsoft.com/office/drawing/2014/main" id="{F0CFAF70-5409-037E-319C-C170E7F30D40}"/>
+              </a:ext>
+            </a:extLst>
+          </p:cNvPr>
+          <p:cNvSpPr>
+            <a:spLocks noGrp="1"/>
+          </p:cNvSpPr>
+          <p:nvPr>
+            <p:ph type="body" sz="quarter" idx="41" hasCustomPrompt="1"/>
+          </p:nvPr>
+        </p:nvSpPr>
+        <p:spPr bwMode="gray">
+          <a:xfrm>
+            <a:off x="6144408" y="3433541"/>
+            <a:ext cx="2640817" cy="1288799"/>
+          </a:xfrm>
+        </p:spPr>
+        <p:txBody>
+          <a:bodyPr/>
+          <a:lstStyle>
+            <a:lvl1pPr>
+              <a:defRPr sz="1600"/>
+            </a:lvl1pPr>
+          </a:lstStyle>
+          <a:p>
+            <a:pPr lvl="0"/>
+            <a:r>
+              <a:rPr lang="de-DE" dirty="0"/>
+              <a:t>Erläuterung hinzufügen</a:t>
+            </a:r>
+          </a:p>
+        </p:txBody>
+      </p:sp>
+      <p:sp>
+        <p:nvSpPr>
+          <p:cNvPr id="33" name="card_3_title">
+            <a:extLst>
+              <a:ext uri="{FF2B5EF4-FFF2-40B4-BE49-F238E27FC236}">
+                <a16:creationId xmlns:a16="http://schemas.microsoft.com/office/drawing/2014/main" id="{C5EA15A9-0090-05A0-788C-04B1815C349D}"/>
+              </a:ext>
+            </a:extLst>
+          </p:cNvPr>
+          <p:cNvSpPr>
+            <a:spLocks noGrp="1"/>
+          </p:cNvSpPr>
+          <p:nvPr>
+            <p:ph type="body" sz="quarter" idx="44" hasCustomPrompt="1"/>
+          </p:nvPr>
+        </p:nvSpPr>
+        <p:spPr bwMode="gray">
+          <a:xfrm>
+            <a:off x="6144408" y="2957944"/>
+            <a:ext cx="2640817" cy="416428"/>
+          </a:xfrm>
+        </p:spPr>
+        <p:txBody>
+          <a:bodyPr anchor="b"/>
+          <a:lstStyle>
+            <a:lvl1pPr>
+              <a:defRPr sz="1600">
+                <a:latin typeface="Wuerth Bold" panose="020B0802020204020204" pitchFamily="34" charset="0"/>
+              </a:defRPr>
+            </a:lvl1pPr>
+          </a:lstStyle>
+          <a:p>
+            <a:pPr lvl="0"/>
+            <a:r>
+              <a:rPr lang="de-DE" dirty="0"/>
+              <a:t>Schlagwort hinzufügen</a:t>
+            </a:r>
+          </a:p>
+        </p:txBody>
+      </p:sp>
+      <p:sp>
+        <p:nvSpPr>
+          <p:cNvPr id="38" name="card_3_visual">
+            <a:extLst>
+              <a:ext uri="{FF2B5EF4-FFF2-40B4-BE49-F238E27FC236}">
+                <a16:creationId xmlns:a16="http://schemas.microsoft.com/office/drawing/2014/main" id="{F6B82FF1-FE0B-D23C-1DF2-6AC2C3D7AA1C}"/>
+              </a:ext>
+            </a:extLst>
+          </p:cNvPr>
+          <p:cNvSpPr>
+            <a:spLocks noGrp="1"/>
+          </p:cNvSpPr>
+          <p:nvPr>
+            <p:ph sz="quarter" idx="47" hasCustomPrompt="1"/>
+          </p:nvPr>
+        </p:nvSpPr>
+        <p:spPr bwMode="gray">
+          <a:xfrm>
+            <a:off x="6144408" y="1225550"/>
+            <a:ext cx="2640817" cy="1673225"/>
+          </a:xfrm>
+        </p:spPr>
+        <p:txBody>
+          <a:bodyPr/>
+          <a:lstStyle>
+            <a:lvl1pPr>
+              <a:defRPr sz="1600"/>
+            </a:lvl1pPr>
+          </a:lstStyle>
+          <a:p>
+            <a:pPr lvl="0"/>
+            <a:r>
+              <a:rPr lang="de-DE" dirty="0"/>
+              <a:t>Inhalte einfügen</a:t>
+            </a:r>
+          </a:p>
+        </p:txBody>
+      </p:sp>
+      <p:sp>
+        <p:nvSpPr>
+          <p:cNvPr id="29" name="card_2_body">
+            <a:extLst>
+              <a:ext uri="{FF2B5EF4-FFF2-40B4-BE49-F238E27FC236}">
+                <a16:creationId xmlns:a16="http://schemas.microsoft.com/office/drawing/2014/main" id="{BEB68C42-895D-6CC2-CD5F-228A6820304D}"/>
+              </a:ext>
+            </a:extLst>
+          </p:cNvPr>
+          <p:cNvSpPr>
+            <a:spLocks noGrp="1"/>
+          </p:cNvSpPr>
+          <p:nvPr>
+            <p:ph type="body" sz="quarter" idx="40" hasCustomPrompt="1"/>
+          </p:nvPr>
+        </p:nvSpPr>
+        <p:spPr bwMode="gray">
+          <a:xfrm>
+            <a:off x="3254029" y="3433540"/>
+            <a:ext cx="2638379" cy="1288800"/>
+          </a:xfrm>
+        </p:spPr>
+        <p:txBody>
+          <a:bodyPr/>
+          <a:lstStyle>
+            <a:lvl1pPr>
+              <a:defRPr sz="1600"/>
+            </a:lvl1pPr>
+          </a:lstStyle>
+          <a:p>
+            <a:pPr lvl="0"/>
+            <a:r>
+              <a:rPr lang="de-DE" dirty="0"/>
+              <a:t>Erläuterung hinzufügen</a:t>
+            </a:r>
+          </a:p>
+        </p:txBody>
+      </p:sp>
+      <p:sp>
+        <p:nvSpPr>
+          <p:cNvPr id="32" name="card_2_title">
+            <a:extLst>
+              <a:ext uri="{FF2B5EF4-FFF2-40B4-BE49-F238E27FC236}">
+                <a16:creationId xmlns:a16="http://schemas.microsoft.com/office/drawing/2014/main" id="{0501E93D-1E0F-17EE-21AB-8E920F7E081F}"/>
+              </a:ext>
+            </a:extLst>
+          </p:cNvPr>
+          <p:cNvSpPr>
+            <a:spLocks noGrp="1"/>
+          </p:cNvSpPr>
+          <p:nvPr>
+            <p:ph type="body" sz="quarter" idx="43" hasCustomPrompt="1"/>
+          </p:nvPr>
+        </p:nvSpPr>
+        <p:spPr bwMode="gray">
+          <a:xfrm>
+            <a:off x="3254375" y="2957944"/>
+            <a:ext cx="2638033" cy="416428"/>
+          </a:xfrm>
+        </p:spPr>
+        <p:txBody>
+          <a:bodyPr anchor="b"/>
+          <a:lstStyle>
+            <a:lvl1pPr>
+              <a:defRPr sz="1600">
+                <a:latin typeface="Wuerth Bold" panose="020B0802020204020204" pitchFamily="34" charset="0"/>
+              </a:defRPr>
+            </a:lvl1pPr>
+          </a:lstStyle>
+          <a:p>
+            <a:pPr lvl="0"/>
+            <a:r>
+              <a:rPr lang="de-DE" dirty="0"/>
+              <a:t>Schlagwort hinzufügen</a:t>
+            </a:r>
+          </a:p>
+        </p:txBody>
+      </p:sp>
+      <p:sp>
+        <p:nvSpPr>
+          <p:cNvPr id="37" name="card_2_visual">
+            <a:extLst>
+              <a:ext uri="{FF2B5EF4-FFF2-40B4-BE49-F238E27FC236}">
+                <a16:creationId xmlns:a16="http://schemas.microsoft.com/office/drawing/2014/main" id="{C6714A35-450D-3CC7-9770-95F8FD453C7E}"/>
+              </a:ext>
+            </a:extLst>
+          </p:cNvPr>
+          <p:cNvSpPr>
+            <a:spLocks noGrp="1"/>
+          </p:cNvSpPr>
+          <p:nvPr>
+            <p:ph sz="quarter" idx="46" hasCustomPrompt="1"/>
+          </p:nvPr>
+        </p:nvSpPr>
+        <p:spPr bwMode="gray">
+          <a:xfrm>
+            <a:off x="3251591" y="1225550"/>
+            <a:ext cx="2640817" cy="1673225"/>
+          </a:xfrm>
+        </p:spPr>
+        <p:txBody>
+          <a:bodyPr/>
+          <a:lstStyle>
+            <a:lvl1pPr>
+              <a:defRPr sz="1600"/>
+            </a:lvl1pPr>
+          </a:lstStyle>
+          <a:p>
+            <a:pPr lvl="0"/>
+            <a:r>
+              <a:rPr lang="de-DE" dirty="0"/>
+              <a:t>Inhalte einfügen</a:t>
+            </a:r>
+          </a:p>
+        </p:txBody>
+      </p:sp>
+      <p:sp>
+        <p:nvSpPr>
+          <p:cNvPr id="28" name="card_1_body">
+            <a:extLst>
+              <a:ext uri="{FF2B5EF4-FFF2-40B4-BE49-F238E27FC236}">
+                <a16:creationId xmlns:a16="http://schemas.microsoft.com/office/drawing/2014/main" id="{4B613E84-B068-9DF6-F799-6DFB2929EBDB}"/>
+              </a:ext>
+            </a:extLst>
+          </p:cNvPr>
+          <p:cNvSpPr>
+            <a:spLocks noGrp="1"/>
+          </p:cNvSpPr>
+          <p:nvPr>
+            <p:ph type="body" sz="quarter" idx="39" hasCustomPrompt="1"/>
+          </p:nvPr>
+        </p:nvSpPr>
+        <p:spPr bwMode="gray">
+          <a:xfrm>
+            <a:off x="358775" y="3433541"/>
+            <a:ext cx="2640817" cy="1288799"/>
+          </a:xfrm>
+        </p:spPr>
+        <p:txBody>
+          <a:bodyPr/>
+          <a:lstStyle>
+            <a:lvl1pPr>
+              <a:defRPr sz="1600"/>
+            </a:lvl1pPr>
+          </a:lstStyle>
+          <a:p>
+            <a:pPr lvl="0"/>
+            <a:r>
+              <a:rPr lang="de-DE" dirty="0"/>
+              <a:t>Erläuterung hinzufügen</a:t>
+            </a:r>
+          </a:p>
+        </p:txBody>
+      </p:sp>
+      <p:sp>
+        <p:nvSpPr>
+          <p:cNvPr id="31" name="card_1_title">
+            <a:extLst>
+              <a:ext uri="{FF2B5EF4-FFF2-40B4-BE49-F238E27FC236}">
+                <a16:creationId xmlns:a16="http://schemas.microsoft.com/office/drawing/2014/main" id="{B59D2F48-A048-2651-2B34-480342A83199}"/>
+              </a:ext>
+            </a:extLst>
+          </p:cNvPr>
+          <p:cNvSpPr>
+            <a:spLocks noGrp="1"/>
+          </p:cNvSpPr>
+          <p:nvPr>
+            <p:ph type="body" sz="quarter" idx="42" hasCustomPrompt="1"/>
+          </p:nvPr>
+        </p:nvSpPr>
+        <p:spPr bwMode="gray">
+          <a:xfrm>
+            <a:off x="358775" y="2957944"/>
+            <a:ext cx="2640817" cy="416428"/>
+          </a:xfrm>
+        </p:spPr>
+        <p:txBody>
+          <a:bodyPr anchor="b"/>
+          <a:lstStyle>
+            <a:lvl1pPr>
+              <a:defRPr sz="1600">
+                <a:latin typeface="Wuerth Bold" panose="020B0802020204020204" pitchFamily="34" charset="0"/>
+              </a:defRPr>
+            </a:lvl1pPr>
+          </a:lstStyle>
+          <a:p>
+            <a:pPr lvl="0"/>
+            <a:r>
+              <a:rPr lang="de-DE" dirty="0"/>
+              <a:t>Schlagwort hinzufügen</a:t>
+            </a:r>
+          </a:p>
+        </p:txBody>
+      </p:sp>
+      <p:sp>
+        <p:nvSpPr>
+          <p:cNvPr id="36" name="card_1_visual">
+            <a:extLst>
+              <a:ext uri="{FF2B5EF4-FFF2-40B4-BE49-F238E27FC236}">
+                <a16:creationId xmlns:a16="http://schemas.microsoft.com/office/drawing/2014/main" id="{FD355AEE-5910-C280-64D1-91D63D01DAAD}"/>
+              </a:ext>
+            </a:extLst>
+          </p:cNvPr>
+          <p:cNvSpPr>
+            <a:spLocks noGrp="1"/>
+          </p:cNvSpPr>
+          <p:nvPr>
+            <p:ph sz="quarter" idx="45" hasCustomPrompt="1"/>
+          </p:nvPr>
+        </p:nvSpPr>
+        <p:spPr bwMode="gray">
+          <a:xfrm>
+            <a:off x="358775" y="1225550"/>
+            <a:ext cx="2640817" cy="1673225"/>
+          </a:xfrm>
+        </p:spPr>
+        <p:txBody>
+          <a:bodyPr/>
+          <a:lstStyle>
+            <a:lvl1pPr>
+              <a:defRPr sz="1600"/>
+            </a:lvl1pPr>
+          </a:lstStyle>
+          <a:p>
+            <a:pPr lvl="0"/>
+            <a:r>
+              <a:rPr lang="de-DE" dirty="0"/>
+              <a:t>Inhalte einfügen</a:t>
+            </a:r>
+          </a:p>
+        </p:txBody>
+      </p:sp>
+      <p:sp>
+        <p:nvSpPr>
+          <p:cNvPr id="10" name="section_label">
             <a:extLst>
               <a:ext uri="{FF2B5EF4-FFF2-40B4-BE49-F238E27FC236}">
                 <a16:creationId xmlns:a16="http://schemas.microsoft.com/office/drawing/2014/main" id="{6AAC659D-5E8A-EDC2-087B-AAE931F68616}"/>
@@ -1889,355 +2380,7 @@
       </p:sp>
       <p:sp>
         <p:nvSpPr>
-          <p:cNvPr id="36" name="Inhaltsplatzhalter 35">
-            <a:extLst>
-              <a:ext uri="{FF2B5EF4-FFF2-40B4-BE49-F238E27FC236}">
-                <a16:creationId xmlns:a16="http://schemas.microsoft.com/office/drawing/2014/main" id="{FD355AEE-5910-C280-64D1-91D63D01DAAD}"/>
-              </a:ext>
-            </a:extLst>
-          </p:cNvPr>
-          <p:cNvSpPr>
-            <a:spLocks noGrp="1"/>
-          </p:cNvSpPr>
-          <p:nvPr>
-            <p:ph sz="quarter" idx="45" hasCustomPrompt="1"/>
-          </p:nvPr>
-        </p:nvSpPr>
-        <p:spPr bwMode="gray">
-          <a:xfrm>
-            <a:off x="358775" y="1225550"/>
-            <a:ext cx="2640817" cy="1673225"/>
-          </a:xfrm>
-        </p:spPr>
-        <p:txBody>
-          <a:bodyPr/>
-          <a:lstStyle>
-            <a:lvl1pPr>
-              <a:defRPr sz="1600"/>
-            </a:lvl1pPr>
-          </a:lstStyle>
-          <a:p>
-            <a:pPr lvl="0"/>
-            <a:r>
-              <a:rPr lang="de-DE" dirty="0"/>
-              <a:t>Inhalte einfügen</a:t>
-            </a:r>
-          </a:p>
-        </p:txBody>
-      </p:sp>
-      <p:sp>
-        <p:nvSpPr>
-          <p:cNvPr id="37" name="Inhaltsplatzhalter 35">
-            <a:extLst>
-              <a:ext uri="{FF2B5EF4-FFF2-40B4-BE49-F238E27FC236}">
-                <a16:creationId xmlns:a16="http://schemas.microsoft.com/office/drawing/2014/main" id="{C6714A35-450D-3CC7-9770-95F8FD453C7E}"/>
-              </a:ext>
-            </a:extLst>
-          </p:cNvPr>
-          <p:cNvSpPr>
-            <a:spLocks noGrp="1"/>
-          </p:cNvSpPr>
-          <p:nvPr>
-            <p:ph sz="quarter" idx="46" hasCustomPrompt="1"/>
-          </p:nvPr>
-        </p:nvSpPr>
-        <p:spPr bwMode="gray">
-          <a:xfrm>
-            <a:off x="3251591" y="1225550"/>
-            <a:ext cx="2640817" cy="1673225"/>
-          </a:xfrm>
-        </p:spPr>
-        <p:txBody>
-          <a:bodyPr/>
-          <a:lstStyle>
-            <a:lvl1pPr>
-              <a:defRPr sz="1600"/>
-            </a:lvl1pPr>
-          </a:lstStyle>
-          <a:p>
-            <a:pPr lvl="0"/>
-            <a:r>
-              <a:rPr lang="de-DE" dirty="0"/>
-              <a:t>Inhalte einfügen</a:t>
-            </a:r>
-          </a:p>
-        </p:txBody>
-      </p:sp>
-      <p:sp>
-        <p:nvSpPr>
-          <p:cNvPr id="38" name="Inhaltsplatzhalter 35">
-            <a:extLst>
-              <a:ext uri="{FF2B5EF4-FFF2-40B4-BE49-F238E27FC236}">
-                <a16:creationId xmlns:a16="http://schemas.microsoft.com/office/drawing/2014/main" id="{F6B82FF1-FE0B-D23C-1DF2-6AC2C3D7AA1C}"/>
-              </a:ext>
-            </a:extLst>
-          </p:cNvPr>
-          <p:cNvSpPr>
-            <a:spLocks noGrp="1"/>
-          </p:cNvSpPr>
-          <p:nvPr>
-            <p:ph sz="quarter" idx="47" hasCustomPrompt="1"/>
-          </p:nvPr>
-        </p:nvSpPr>
-        <p:spPr bwMode="gray">
-          <a:xfrm>
-            <a:off x="6144408" y="1225550"/>
-            <a:ext cx="2640817" cy="1673225"/>
-          </a:xfrm>
-        </p:spPr>
-        <p:txBody>
-          <a:bodyPr/>
-          <a:lstStyle>
-            <a:lvl1pPr>
-              <a:defRPr sz="1600"/>
-            </a:lvl1pPr>
-          </a:lstStyle>
-          <a:p>
-            <a:pPr lvl="0"/>
-            <a:r>
-              <a:rPr lang="de-DE" dirty="0"/>
-              <a:t>Inhalte einfügen</a:t>
-            </a:r>
-          </a:p>
-        </p:txBody>
-      </p:sp>
-      <p:sp>
-        <p:nvSpPr>
-          <p:cNvPr id="28" name="Textplatzhalter 27">
-            <a:extLst>
-              <a:ext uri="{FF2B5EF4-FFF2-40B4-BE49-F238E27FC236}">
-                <a16:creationId xmlns:a16="http://schemas.microsoft.com/office/drawing/2014/main" id="{4B613E84-B068-9DF6-F799-6DFB2929EBDB}"/>
-              </a:ext>
-            </a:extLst>
-          </p:cNvPr>
-          <p:cNvSpPr>
-            <a:spLocks noGrp="1"/>
-          </p:cNvSpPr>
-          <p:nvPr>
-            <p:ph type="body" sz="quarter" idx="39" hasCustomPrompt="1"/>
-          </p:nvPr>
-        </p:nvSpPr>
-        <p:spPr bwMode="gray">
-          <a:xfrm>
-            <a:off x="358775" y="3433541"/>
-            <a:ext cx="2640817" cy="1288799"/>
-          </a:xfrm>
-        </p:spPr>
-        <p:txBody>
-          <a:bodyPr/>
-          <a:lstStyle>
-            <a:lvl1pPr>
-              <a:defRPr sz="1600"/>
-            </a:lvl1pPr>
-          </a:lstStyle>
-          <a:p>
-            <a:pPr lvl="0"/>
-            <a:r>
-              <a:rPr lang="de-DE" dirty="0"/>
-              <a:t>Erläuterung hinzufügen</a:t>
-            </a:r>
-          </a:p>
-        </p:txBody>
-      </p:sp>
-      <p:sp>
-        <p:nvSpPr>
-          <p:cNvPr id="29" name="Textplatzhalter 27">
-            <a:extLst>
-              <a:ext uri="{FF2B5EF4-FFF2-40B4-BE49-F238E27FC236}">
-                <a16:creationId xmlns:a16="http://schemas.microsoft.com/office/drawing/2014/main" id="{BEB68C42-895D-6CC2-CD5F-228A6820304D}"/>
-              </a:ext>
-            </a:extLst>
-          </p:cNvPr>
-          <p:cNvSpPr>
-            <a:spLocks noGrp="1"/>
-          </p:cNvSpPr>
-          <p:nvPr>
-            <p:ph type="body" sz="quarter" idx="40" hasCustomPrompt="1"/>
-          </p:nvPr>
-        </p:nvSpPr>
-        <p:spPr bwMode="gray">
-          <a:xfrm>
-            <a:off x="3254029" y="3433540"/>
-            <a:ext cx="2638379" cy="1288800"/>
-          </a:xfrm>
-        </p:spPr>
-        <p:txBody>
-          <a:bodyPr/>
-          <a:lstStyle>
-            <a:lvl1pPr>
-              <a:defRPr sz="1600"/>
-            </a:lvl1pPr>
-          </a:lstStyle>
-          <a:p>
-            <a:pPr lvl="0"/>
-            <a:r>
-              <a:rPr lang="de-DE" dirty="0"/>
-              <a:t>Erläuterung hinzufügen</a:t>
-            </a:r>
-          </a:p>
-        </p:txBody>
-      </p:sp>
-      <p:sp>
-        <p:nvSpPr>
-          <p:cNvPr id="30" name="Textplatzhalter 27">
-            <a:extLst>
-              <a:ext uri="{FF2B5EF4-FFF2-40B4-BE49-F238E27FC236}">
-                <a16:creationId xmlns:a16="http://schemas.microsoft.com/office/drawing/2014/main" id="{F0CFAF70-5409-037E-319C-C170E7F30D40}"/>
-              </a:ext>
-            </a:extLst>
-          </p:cNvPr>
-          <p:cNvSpPr>
-            <a:spLocks noGrp="1"/>
-          </p:cNvSpPr>
-          <p:nvPr>
-            <p:ph type="body" sz="quarter" idx="41" hasCustomPrompt="1"/>
-          </p:nvPr>
-        </p:nvSpPr>
-        <p:spPr bwMode="gray">
-          <a:xfrm>
-            <a:off x="6144408" y="3433541"/>
-            <a:ext cx="2640817" cy="1288799"/>
-          </a:xfrm>
-        </p:spPr>
-        <p:txBody>
-          <a:bodyPr/>
-          <a:lstStyle>
-            <a:lvl1pPr>
-              <a:defRPr sz="1600"/>
-            </a:lvl1pPr>
-          </a:lstStyle>
-          <a:p>
-            <a:pPr lvl="0"/>
-            <a:r>
-              <a:rPr lang="de-DE" dirty="0"/>
-              <a:t>Erläuterung hinzufügen</a:t>
-            </a:r>
-          </a:p>
-        </p:txBody>
-      </p:sp>
-      <p:sp>
-        <p:nvSpPr>
-          <p:cNvPr id="31" name="Textplatzhalter 27">
-            <a:extLst>
-              <a:ext uri="{FF2B5EF4-FFF2-40B4-BE49-F238E27FC236}">
-                <a16:creationId xmlns:a16="http://schemas.microsoft.com/office/drawing/2014/main" id="{B59D2F48-A048-2651-2B34-480342A83199}"/>
-              </a:ext>
-            </a:extLst>
-          </p:cNvPr>
-          <p:cNvSpPr>
-            <a:spLocks noGrp="1"/>
-          </p:cNvSpPr>
-          <p:nvPr>
-            <p:ph type="body" sz="quarter" idx="42" hasCustomPrompt="1"/>
-          </p:nvPr>
-        </p:nvSpPr>
-        <p:spPr bwMode="gray">
-          <a:xfrm>
-            <a:off x="358775" y="2957944"/>
-            <a:ext cx="2640817" cy="416428"/>
-          </a:xfrm>
-        </p:spPr>
-        <p:txBody>
-          <a:bodyPr anchor="b"/>
-          <a:lstStyle>
-            <a:lvl1pPr>
-              <a:defRPr sz="1600">
-                <a:latin typeface="Wuerth Bold" panose="020B0802020204020204" pitchFamily="34" charset="0"/>
-              </a:defRPr>
-            </a:lvl1pPr>
-          </a:lstStyle>
-          <a:p>
-            <a:pPr lvl="0"/>
-            <a:r>
-              <a:rPr lang="de-DE" dirty="0"/>
-              <a:t>Schlagwort hinzufügen</a:t>
-            </a:r>
-          </a:p>
-        </p:txBody>
-      </p:sp>
-      <p:sp>
-        <p:nvSpPr>
-          <p:cNvPr id="32" name="Textplatzhalter 27">
-            <a:extLst>
-              <a:ext uri="{FF2B5EF4-FFF2-40B4-BE49-F238E27FC236}">
-                <a16:creationId xmlns:a16="http://schemas.microsoft.com/office/drawing/2014/main" id="{0501E93D-1E0F-17EE-21AB-8E920F7E081F}"/>
-              </a:ext>
-            </a:extLst>
-          </p:cNvPr>
-          <p:cNvSpPr>
-            <a:spLocks noGrp="1"/>
-          </p:cNvSpPr>
-          <p:nvPr>
-            <p:ph type="body" sz="quarter" idx="43" hasCustomPrompt="1"/>
-          </p:nvPr>
-        </p:nvSpPr>
-        <p:spPr bwMode="gray">
-          <a:xfrm>
-            <a:off x="3254375" y="2957944"/>
-            <a:ext cx="2638033" cy="416428"/>
-          </a:xfrm>
-        </p:spPr>
-        <p:txBody>
-          <a:bodyPr anchor="b"/>
-          <a:lstStyle>
-            <a:lvl1pPr>
-              <a:defRPr sz="1600">
-                <a:latin typeface="Wuerth Bold" panose="020B0802020204020204" pitchFamily="34" charset="0"/>
-              </a:defRPr>
-            </a:lvl1pPr>
-          </a:lstStyle>
-          <a:p>
-            <a:pPr lvl="0"/>
-            <a:r>
-              <a:rPr lang="de-DE" dirty="0"/>
-              <a:t>Schlagwort hinzufügen</a:t>
-            </a:r>
-          </a:p>
-        </p:txBody>
-      </p:sp>
-      <p:sp>
-        <p:nvSpPr>
-          <p:cNvPr id="33" name="Textplatzhalter 27">
-            <a:extLst>
-              <a:ext uri="{FF2B5EF4-FFF2-40B4-BE49-F238E27FC236}">
-                <a16:creationId xmlns:a16="http://schemas.microsoft.com/office/drawing/2014/main" id="{C5EA15A9-0090-05A0-788C-04B1815C349D}"/>
-              </a:ext>
-            </a:extLst>
-          </p:cNvPr>
-          <p:cNvSpPr>
-            <a:spLocks noGrp="1"/>
-          </p:cNvSpPr>
-          <p:nvPr>
-            <p:ph type="body" sz="quarter" idx="44" hasCustomPrompt="1"/>
-          </p:nvPr>
-        </p:nvSpPr>
-        <p:spPr bwMode="gray">
-          <a:xfrm>
-            <a:off x="6144408" y="2957944"/>
-            <a:ext cx="2640817" cy="416428"/>
-          </a:xfrm>
-        </p:spPr>
-        <p:txBody>
-          <a:bodyPr anchor="b"/>
-          <a:lstStyle>
-            <a:lvl1pPr>
-              <a:defRPr sz="1600">
-                <a:latin typeface="Wuerth Bold" panose="020B0802020204020204" pitchFamily="34" charset="0"/>
-              </a:defRPr>
-            </a:lvl1pPr>
-          </a:lstStyle>
-          <a:p>
-            <a:pPr lvl="0"/>
-            <a:r>
-              <a:rPr lang="de-DE" dirty="0"/>
-              <a:t>Schlagwort hinzufügen</a:t>
-            </a:r>
-          </a:p>
-        </p:txBody>
-      </p:sp>
-      <p:sp>
-        <p:nvSpPr>
-          <p:cNvPr id="17" name="Titel 16">
+          <p:cNvPr id="17" name="title">
             <a:extLst>
               <a:ext uri="{FF2B5EF4-FFF2-40B4-BE49-F238E27FC236}">
                 <a16:creationId xmlns:a16="http://schemas.microsoft.com/office/drawing/2014/main" id="{BBE023E1-3584-2BDA-6957-2E3CAA4DA2DF}"/>
@@ -2248,107 +2391,18 @@
             <a:spLocks noGrp="1"/>
           </p:cNvSpPr>
           <p:nvPr>
-            <p:ph type="title"/>
+            <p:ph type="title" hasCustomPrompt="1"/>
           </p:nvPr>
         </p:nvSpPr>
         <p:spPr bwMode="gray"/>
         <p:txBody>
-          <a:bodyPr vert="horz"/>
+          <a:bodyPr vert="horz" rIns="0"/>
           <a:lstStyle/>
           <a:p>
             <a:r>
               <a:rPr lang="de-DE" dirty="0"/>
               <a:t>Mastertitelformat bearbeiten</a:t>
             </a:r>
-          </a:p>
-        </p:txBody>
-      </p:sp>
-      <p:sp>
-        <p:nvSpPr>
-          <p:cNvPr id="4" name="Datumsplatzhalter 3">
-            <a:extLst>
-              <a:ext uri="{FF2B5EF4-FFF2-40B4-BE49-F238E27FC236}">
-                <a16:creationId xmlns:a16="http://schemas.microsoft.com/office/drawing/2014/main" id="{207DB444-F5E1-C978-374D-AC897C8F71DD}"/>
-              </a:ext>
-            </a:extLst>
-          </p:cNvPr>
-          <p:cNvSpPr>
-            <a:spLocks noGrp="1"/>
-          </p:cNvSpPr>
-          <p:nvPr>
-            <p:ph type="dt" sz="half" idx="48"/>
-          </p:nvPr>
-        </p:nvSpPr>
-        <p:spPr/>
-        <p:txBody>
-          <a:bodyPr/>
-          <a:lstStyle/>
-          <a:p>
-            <a:pPr indent="-468000"/>
-            <a:fld id="{84284A58-3EB3-4F57-9112-3DEC02019146}" type="datetime1">
-              <a:rPr lang="de-DE" smtClean="0"/>
-              <a:t>21.06.2026</a:t>
-            </a:fld>
-            <a:endParaRPr lang="de-DE" dirty="0"/>
-          </a:p>
-        </p:txBody>
-      </p:sp>
-      <p:sp>
-        <p:nvSpPr>
-          <p:cNvPr id="6" name="Fußzeilenplatzhalter 5">
-            <a:extLst>
-              <a:ext uri="{FF2B5EF4-FFF2-40B4-BE49-F238E27FC236}">
-                <a16:creationId xmlns:a16="http://schemas.microsoft.com/office/drawing/2014/main" id="{2A990709-5D8D-EA81-4798-B6BF38043537}"/>
-              </a:ext>
-            </a:extLst>
-          </p:cNvPr>
-          <p:cNvSpPr>
-            <a:spLocks noGrp="1"/>
-          </p:cNvSpPr>
-          <p:nvPr>
-            <p:ph type="ftr" sz="quarter" idx="49"/>
-          </p:nvPr>
-        </p:nvSpPr>
-        <p:spPr/>
-        <p:txBody>
-          <a:bodyPr/>
-          <a:lstStyle/>
-          <a:p>
-            <a:pPr indent="-468000"/>
-            <a:r>
-              <a:rPr lang="de-DE" dirty="0"/>
-              <a:t>Würth Line Folienmaster</a:t>
-            </a:r>
-          </a:p>
-        </p:txBody>
-      </p:sp>
-      <p:sp>
-        <p:nvSpPr>
-          <p:cNvPr id="7" name="Foliennummernplatzhalter 6">
-            <a:extLst>
-              <a:ext uri="{FF2B5EF4-FFF2-40B4-BE49-F238E27FC236}">
-                <a16:creationId xmlns:a16="http://schemas.microsoft.com/office/drawing/2014/main" id="{FC516280-B4E8-8716-E5BF-5BD12DC9E791}"/>
-              </a:ext>
-            </a:extLst>
-          </p:cNvPr>
-          <p:cNvSpPr>
-            <a:spLocks noGrp="1"/>
-          </p:cNvSpPr>
-          <p:nvPr>
-            <p:ph type="sldNum" sz="quarter" idx="50"/>
-          </p:nvPr>
-        </p:nvSpPr>
-        <p:spPr/>
-        <p:txBody>
-          <a:bodyPr/>
-          <a:lstStyle/>
-          <a:p>
-            <a:fld id="{3CBD43C5-A65B-4791-8A9A-EB6408C246D1}" type="slidenum">
-              <a:rPr lang="de-DE" smtClean="0"/>
-              <a:pPr/>
-              <a:t>‹#›</a:t>
-            </a:fld>
-            <a:endParaRPr lang="de-DE" dirty="0"/>
           </a:p>
         </p:txBody>
       </p:sp>
@@ -2393,7 +2447,7 @@
 
 <file path=ppt/slideLayouts/slideLayout4.xml><?xml version="1.0" encoding="utf-8"?>
 <p:sldLayout xmlns:a="http://schemas.openxmlformats.org/drawingml/2006/main" xmlns:r="http://schemas.openxmlformats.org/officeDocument/2006/relationships" xmlns:p="http://schemas.openxmlformats.org/presentationml/2006/main" preserve="1" userDrawn="1">
-  <p:cSld name="Agent 04 Chart Evidence">
+  <p:cSld name="agent_04_two_column">
     <p:spTree>
       <p:nvGrpSpPr>
         <p:cNvPr id="1" name=""/>
@@ -2482,7 +2536,220 @@
       </p:graphicFrame>
       <p:sp>
         <p:nvSpPr>
-          <p:cNvPr id="12" name="Textplatzhalter 11">
+          <p:cNvPr id="6" name="footer_date">
+            <a:extLst>
+              <a:ext uri="{FF2B5EF4-FFF2-40B4-BE49-F238E27FC236}">
+                <a16:creationId xmlns:a16="http://schemas.microsoft.com/office/drawing/2014/main" id="{DB796F3B-31DB-4E07-EEE3-3423AE2D9438}"/>
+              </a:ext>
+            </a:extLst>
+          </p:cNvPr>
+          <p:cNvSpPr>
+            <a:spLocks noGrp="1"/>
+          </p:cNvSpPr>
+          <p:nvPr>
+            <p:ph type="dt" sz="half" idx="35"/>
+          </p:nvPr>
+        </p:nvSpPr>
+        <p:spPr/>
+        <p:txBody>
+          <a:bodyPr/>
+          <a:lstStyle/>
+          <a:p>
+            <a:pPr indent="-468000"/>
+            <a:fld id="{84284A58-3EB3-4F57-9112-3DEC02019146}" type="datetime1">
+              <a:rPr lang="de-DE" smtClean="0"/>
+              <a:t>22.06.2026</a:t>
+            </a:fld>
+            <a:endParaRPr lang="de-DE" dirty="0"/>
+          </a:p>
+        </p:txBody>
+      </p:sp>
+      <p:sp>
+        <p:nvSpPr>
+          <p:cNvPr id="8" name="footer_source">
+            <a:extLst>
+              <a:ext uri="{FF2B5EF4-FFF2-40B4-BE49-F238E27FC236}">
+                <a16:creationId xmlns:a16="http://schemas.microsoft.com/office/drawing/2014/main" id="{028E38A9-4BE6-1EC4-10D8-972E3E9AC097}"/>
+              </a:ext>
+            </a:extLst>
+          </p:cNvPr>
+          <p:cNvSpPr>
+            <a:spLocks noGrp="1"/>
+          </p:cNvSpPr>
+          <p:nvPr>
+            <p:ph type="ftr" sz="quarter" idx="36"/>
+          </p:nvPr>
+        </p:nvSpPr>
+        <p:spPr/>
+        <p:txBody>
+          <a:bodyPr/>
+          <a:lstStyle/>
+          <a:p>
+            <a:pPr indent="-468000"/>
+            <a:r>
+              <a:rPr lang="de-DE" dirty="0"/>
+              <a:t>Würth Line Folienmaster</a:t>
+            </a:r>
+          </a:p>
+        </p:txBody>
+      </p:sp>
+      <p:sp>
+        <p:nvSpPr>
+          <p:cNvPr id="9" name="footer_slide_number">
+            <a:extLst>
+              <a:ext uri="{FF2B5EF4-FFF2-40B4-BE49-F238E27FC236}">
+                <a16:creationId xmlns:a16="http://schemas.microsoft.com/office/drawing/2014/main" id="{EA2CA06C-F981-299C-7395-E30D91BD4900}"/>
+              </a:ext>
+            </a:extLst>
+          </p:cNvPr>
+          <p:cNvSpPr>
+            <a:spLocks noGrp="1"/>
+          </p:cNvSpPr>
+          <p:nvPr>
+            <p:ph type="sldNum" sz="quarter" idx="37"/>
+          </p:nvPr>
+        </p:nvSpPr>
+        <p:spPr/>
+        <p:txBody>
+          <a:bodyPr/>
+          <a:lstStyle/>
+          <a:p>
+            <a:fld id="{3CBD43C5-A65B-4791-8A9A-EB6408C246D1}" type="slidenum">
+              <a:rPr lang="de-DE" smtClean="0"/>
+              <a:pPr/>
+              <a:t>‹#›</a:t>
+            </a:fld>
+            <a:endParaRPr lang="de-DE" dirty="0"/>
+          </a:p>
+        </p:txBody>
+      </p:sp>
+      <p:sp>
+        <p:nvSpPr>
+          <p:cNvPr id="5" name="right_body">
+            <a:extLst>
+              <a:ext uri="{FF2B5EF4-FFF2-40B4-BE49-F238E27FC236}">
+                <a16:creationId xmlns:a16="http://schemas.microsoft.com/office/drawing/2014/main" id="{481CC3E1-657C-885A-CA56-4EBA34B3D258}"/>
+              </a:ext>
+            </a:extLst>
+          </p:cNvPr>
+          <p:cNvSpPr>
+            <a:spLocks noGrp="1"/>
+          </p:cNvSpPr>
+          <p:nvPr>
+            <p:ph sz="quarter" idx="32"/>
+          </p:nvPr>
+        </p:nvSpPr>
+        <p:spPr bwMode="gray">
+          <a:xfrm>
+            <a:off x="6048375" y="1230109"/>
+            <a:ext cx="2736850" cy="3492001"/>
+          </a:xfrm>
+        </p:spPr>
+        <p:txBody>
+          <a:bodyPr/>
+          <a:lstStyle/>
+          <a:p>
+            <a:pPr lvl="0"/>
+            <a:r>
+              <a:rPr lang="de-DE" dirty="0"/>
+              <a:t>Mastertextformat bearbeiten</a:t>
+            </a:r>
+          </a:p>
+          <a:p>
+            <a:pPr lvl="1"/>
+            <a:r>
+              <a:rPr lang="de-DE" dirty="0"/>
+              <a:t>Zweite Ebene</a:t>
+            </a:r>
+          </a:p>
+          <a:p>
+            <a:pPr lvl="2"/>
+            <a:r>
+              <a:rPr lang="de-DE" dirty="0"/>
+              <a:t>Dritte Ebene</a:t>
+            </a:r>
+          </a:p>
+          <a:p>
+            <a:pPr lvl="3"/>
+            <a:r>
+              <a:rPr lang="de-DE" dirty="0"/>
+              <a:t>Vierte Ebene</a:t>
+            </a:r>
+          </a:p>
+          <a:p>
+            <a:pPr lvl="4"/>
+            <a:r>
+              <a:rPr lang="de-DE" dirty="0"/>
+              <a:t>Fünfte Ebene</a:t>
+            </a:r>
+          </a:p>
+        </p:txBody>
+      </p:sp>
+      <p:sp>
+        <p:nvSpPr>
+          <p:cNvPr id="4" name="left_body">
+            <a:extLst>
+              <a:ext uri="{FF2B5EF4-FFF2-40B4-BE49-F238E27FC236}">
+                <a16:creationId xmlns:a16="http://schemas.microsoft.com/office/drawing/2014/main" id="{4ECC0F70-05A5-0FFD-51C2-CEAB1060149A}"/>
+              </a:ext>
+            </a:extLst>
+          </p:cNvPr>
+          <p:cNvSpPr>
+            <a:spLocks noGrp="1"/>
+          </p:cNvSpPr>
+          <p:nvPr>
+            <p:ph sz="quarter" idx="34"/>
+          </p:nvPr>
+        </p:nvSpPr>
+        <p:spPr bwMode="gray">
+          <a:xfrm>
+            <a:off x="358775" y="1230110"/>
+            <a:ext cx="5545598" cy="3492000"/>
+          </a:xfrm>
+        </p:spPr>
+        <p:txBody>
+          <a:bodyPr/>
+          <a:lstStyle/>
+          <a:p>
+            <a:pPr lvl="0"/>
+            <a:r>
+              <a:rPr lang="de-DE" dirty="0"/>
+              <a:t>Mastertextformat bearbeiten</a:t>
+            </a:r>
+          </a:p>
+          <a:p>
+            <a:pPr lvl="1"/>
+            <a:r>
+              <a:rPr lang="de-DE" dirty="0"/>
+              <a:t>Zweite Ebene</a:t>
+            </a:r>
+          </a:p>
+          <a:p>
+            <a:pPr lvl="2"/>
+            <a:r>
+              <a:rPr lang="de-DE" dirty="0"/>
+              <a:t>Dritte Ebene</a:t>
+            </a:r>
+          </a:p>
+          <a:p>
+            <a:pPr lvl="3"/>
+            <a:r>
+              <a:rPr lang="de-DE" dirty="0"/>
+              <a:t>Vierte Ebene</a:t>
+            </a:r>
+          </a:p>
+          <a:p>
+            <a:pPr lvl="4"/>
+            <a:r>
+              <a:rPr lang="de-DE" dirty="0"/>
+              <a:t>Fünfte Ebene</a:t>
+            </a:r>
+          </a:p>
+        </p:txBody>
+      </p:sp>
+      <p:sp>
+        <p:nvSpPr>
+          <p:cNvPr id="12" name="section_label">
             <a:extLst>
               <a:ext uri="{FF2B5EF4-FFF2-40B4-BE49-F238E27FC236}">
                 <a16:creationId xmlns:a16="http://schemas.microsoft.com/office/drawing/2014/main" id="{E4BB559A-959F-E065-EED1-B99203950C30}"/>
@@ -2597,242 +2864,29 @@
       </p:sp>
       <p:sp>
         <p:nvSpPr>
-          <p:cNvPr id="5" name="Inhaltsplatzhalter 9">
-            <a:extLst>
-              <a:ext uri="{FF2B5EF4-FFF2-40B4-BE49-F238E27FC236}">
-                <a16:creationId xmlns:a16="http://schemas.microsoft.com/office/drawing/2014/main" id="{481CC3E1-657C-885A-CA56-4EBA34B3D258}"/>
-              </a:ext>
-            </a:extLst>
-          </p:cNvPr>
-          <p:cNvSpPr>
-            <a:spLocks noGrp="1"/>
-          </p:cNvSpPr>
-          <p:nvPr>
-            <p:ph sz="quarter" idx="32"/>
-          </p:nvPr>
-        </p:nvSpPr>
-        <p:spPr bwMode="gray">
-          <a:xfrm>
-            <a:off x="6048375" y="1230109"/>
-            <a:ext cx="2736850" cy="3492001"/>
-          </a:xfrm>
-        </p:spPr>
-        <p:txBody>
-          <a:bodyPr/>
+          <p:cNvPr id="23" name="title">
+            <a:extLst>
+              <a:ext uri="{FF2B5EF4-FFF2-40B4-BE49-F238E27FC236}">
+                <a16:creationId xmlns:a16="http://schemas.microsoft.com/office/drawing/2014/main" id="{D7DB9E0C-0A01-30F9-EB8B-F8B9525110F1}"/>
+              </a:ext>
+            </a:extLst>
+          </p:cNvPr>
+          <p:cNvSpPr>
+            <a:spLocks noGrp="1"/>
+          </p:cNvSpPr>
+          <p:nvPr>
+            <p:ph type="title" hasCustomPrompt="1"/>
+          </p:nvPr>
+        </p:nvSpPr>
+        <p:spPr bwMode="gray"/>
+        <p:txBody>
+          <a:bodyPr vert="horz" rIns="0"/>
           <a:lstStyle/>
           <a:p>
-            <a:pPr lvl="0"/>
-            <a:r>
-              <a:rPr lang="de-DE" dirty="0"/>
-              <a:t>Mastertextformat bearbeiten</a:t>
-            </a:r>
-          </a:p>
-          <a:p>
-            <a:pPr lvl="1"/>
-            <a:r>
-              <a:rPr lang="de-DE" dirty="0"/>
-              <a:t>Zweite Ebene</a:t>
-            </a:r>
-          </a:p>
-          <a:p>
-            <a:pPr lvl="2"/>
-            <a:r>
-              <a:rPr lang="de-DE" dirty="0"/>
-              <a:t>Dritte Ebene</a:t>
-            </a:r>
-          </a:p>
-          <a:p>
-            <a:pPr lvl="3"/>
-            <a:r>
-              <a:rPr lang="de-DE" dirty="0"/>
-              <a:t>Vierte Ebene</a:t>
-            </a:r>
-          </a:p>
-          <a:p>
-            <a:pPr lvl="4"/>
-            <a:r>
-              <a:rPr lang="de-DE" dirty="0"/>
-              <a:t>Fünfte Ebene</a:t>
-            </a:r>
-          </a:p>
-        </p:txBody>
-      </p:sp>
-      <p:sp>
-        <p:nvSpPr>
-          <p:cNvPr id="4" name="Inhaltsplatzhalter 3">
-            <a:extLst>
-              <a:ext uri="{FF2B5EF4-FFF2-40B4-BE49-F238E27FC236}">
-                <a16:creationId xmlns:a16="http://schemas.microsoft.com/office/drawing/2014/main" id="{4ECC0F70-05A5-0FFD-51C2-CEAB1060149A}"/>
-              </a:ext>
-            </a:extLst>
-          </p:cNvPr>
-          <p:cNvSpPr>
-            <a:spLocks noGrp="1"/>
-          </p:cNvSpPr>
-          <p:nvPr>
-            <p:ph sz="quarter" idx="34"/>
-          </p:nvPr>
-        </p:nvSpPr>
-        <p:spPr bwMode="gray">
-          <a:xfrm>
-            <a:off x="358775" y="1230110"/>
-            <a:ext cx="5545598" cy="3492000"/>
-          </a:xfrm>
-        </p:spPr>
-        <p:txBody>
-          <a:bodyPr/>
-          <a:lstStyle/>
-          <a:p>
-            <a:pPr lvl="0"/>
-            <a:r>
-              <a:rPr lang="de-DE" dirty="0"/>
-              <a:t>Mastertextformat bearbeiten</a:t>
-            </a:r>
-          </a:p>
-          <a:p>
-            <a:pPr lvl="1"/>
-            <a:r>
-              <a:rPr lang="de-DE" dirty="0"/>
-              <a:t>Zweite Ebene</a:t>
-            </a:r>
-          </a:p>
-          <a:p>
-            <a:pPr lvl="2"/>
-            <a:r>
-              <a:rPr lang="de-DE" dirty="0"/>
-              <a:t>Dritte Ebene</a:t>
-            </a:r>
-          </a:p>
-          <a:p>
-            <a:pPr lvl="3"/>
-            <a:r>
-              <a:rPr lang="de-DE" dirty="0"/>
-              <a:t>Vierte Ebene</a:t>
-            </a:r>
-          </a:p>
-          <a:p>
-            <a:pPr lvl="4"/>
-            <a:r>
-              <a:rPr lang="de-DE" dirty="0"/>
-              <a:t>Fünfte Ebene</a:t>
-            </a:r>
-          </a:p>
-        </p:txBody>
-      </p:sp>
-      <p:sp>
-        <p:nvSpPr>
-          <p:cNvPr id="23" name="Titel 22">
-            <a:extLst>
-              <a:ext uri="{FF2B5EF4-FFF2-40B4-BE49-F238E27FC236}">
-                <a16:creationId xmlns:a16="http://schemas.microsoft.com/office/drawing/2014/main" id="{D7DB9E0C-0A01-30F9-EB8B-F8B9525110F1}"/>
-              </a:ext>
-            </a:extLst>
-          </p:cNvPr>
-          <p:cNvSpPr>
-            <a:spLocks noGrp="1"/>
-          </p:cNvSpPr>
-          <p:nvPr>
-            <p:ph type="title"/>
-          </p:nvPr>
-        </p:nvSpPr>
-        <p:spPr bwMode="gray"/>
-        <p:txBody>
-          <a:bodyPr vert="horz"/>
-          <a:lstStyle/>
-          <a:p>
             <a:r>
               <a:rPr lang="de-DE" dirty="0"/>
               <a:t>Mastertitelformat bearbeiten</a:t>
             </a:r>
-          </a:p>
-        </p:txBody>
-      </p:sp>
-      <p:sp>
-        <p:nvSpPr>
-          <p:cNvPr id="6" name="Datumsplatzhalter 5">
-            <a:extLst>
-              <a:ext uri="{FF2B5EF4-FFF2-40B4-BE49-F238E27FC236}">
-                <a16:creationId xmlns:a16="http://schemas.microsoft.com/office/drawing/2014/main" id="{DB796F3B-31DB-4E07-EEE3-3423AE2D9438}"/>
-              </a:ext>
-            </a:extLst>
-          </p:cNvPr>
-          <p:cNvSpPr>
-            <a:spLocks noGrp="1"/>
-          </p:cNvSpPr>
-          <p:nvPr>
-            <p:ph type="dt" sz="half" idx="35"/>
-          </p:nvPr>
-        </p:nvSpPr>
-        <p:spPr/>
-        <p:txBody>
-          <a:bodyPr/>
-          <a:lstStyle/>
-          <a:p>
-            <a:pPr indent="-468000"/>
-            <a:fld id="{84284A58-3EB3-4F57-9112-3DEC02019146}" type="datetime1">
-              <a:rPr lang="de-DE" smtClean="0"/>
-              <a:t>21.06.2026</a:t>
-            </a:fld>
-            <a:endParaRPr lang="de-DE" dirty="0"/>
-          </a:p>
-        </p:txBody>
-      </p:sp>
-      <p:sp>
-        <p:nvSpPr>
-          <p:cNvPr id="8" name="Fußzeilenplatzhalter 7">
-            <a:extLst>
-              <a:ext uri="{FF2B5EF4-FFF2-40B4-BE49-F238E27FC236}">
-                <a16:creationId xmlns:a16="http://schemas.microsoft.com/office/drawing/2014/main" id="{028E38A9-4BE6-1EC4-10D8-972E3E9AC097}"/>
-              </a:ext>
-            </a:extLst>
-          </p:cNvPr>
-          <p:cNvSpPr>
-            <a:spLocks noGrp="1"/>
-          </p:cNvSpPr>
-          <p:nvPr>
-            <p:ph type="ftr" sz="quarter" idx="36"/>
-          </p:nvPr>
-        </p:nvSpPr>
-        <p:spPr/>
-        <p:txBody>
-          <a:bodyPr/>
-          <a:lstStyle/>
-          <a:p>
-            <a:pPr indent="-468000"/>
-            <a:r>
-              <a:rPr lang="de-DE" dirty="0"/>
-              <a:t>Würth Line Folienmaster</a:t>
-            </a:r>
-          </a:p>
-        </p:txBody>
-      </p:sp>
-      <p:sp>
-        <p:nvSpPr>
-          <p:cNvPr id="9" name="Foliennummernplatzhalter 8">
-            <a:extLst>
-              <a:ext uri="{FF2B5EF4-FFF2-40B4-BE49-F238E27FC236}">
-                <a16:creationId xmlns:a16="http://schemas.microsoft.com/office/drawing/2014/main" id="{EA2CA06C-F981-299C-7395-E30D91BD4900}"/>
-              </a:ext>
-            </a:extLst>
-          </p:cNvPr>
-          <p:cNvSpPr>
-            <a:spLocks noGrp="1"/>
-          </p:cNvSpPr>
-          <p:nvPr>
-            <p:ph type="sldNum" sz="quarter" idx="37"/>
-          </p:nvPr>
-        </p:nvSpPr>
-        <p:spPr/>
-        <p:txBody>
-          <a:bodyPr/>
-          <a:lstStyle/>
-          <a:p>
-            <a:fld id="{3CBD43C5-A65B-4791-8A9A-EB6408C246D1}" type="slidenum">
-              <a:rPr lang="de-DE" smtClean="0"/>
-              <a:pPr/>
-              <a:t>‹#›</a:t>
-            </a:fld>
-            <a:endParaRPr lang="de-DE" dirty="0"/>
           </a:p>
         </p:txBody>
       </p:sp>
@@ -2867,7 +2921,7 @@
 
 <file path=ppt/slideLayouts/slideLayout5.xml><?xml version="1.0" encoding="utf-8"?>
 <p:sldLayout xmlns:a="http://schemas.openxmlformats.org/drawingml/2006/main" xmlns:r="http://schemas.openxmlformats.org/officeDocument/2006/relationships" xmlns:p="http://schemas.openxmlformats.org/presentationml/2006/main" preserve="1" userDrawn="1">
-  <p:cSld name="Agent 05 Table Evidence">
+  <p:cSld name="agent_05_full_content">
     <p:spTree>
       <p:nvGrpSpPr>
         <p:cNvPr id="1" name=""/>
@@ -2900,7 +2954,7 @@
             </p:custDataLst>
             <p:extLst>
               <p:ext uri="{D42A27DB-BD31-4B8C-83A1-F6EECF244321}">
-                <p14:modId xmlns:p14="http://schemas.microsoft.com/office/powerpoint/2010/main" val="2848507216"/>
+                <p14:modId xmlns:p14="http://schemas.microsoft.com/office/powerpoint/2010/main" val="3376174090"/>
               </p:ext>
             </p:extLst>
           </p:nvPr>
@@ -2956,7 +3010,96 @@
       </p:graphicFrame>
       <p:sp>
         <p:nvSpPr>
-          <p:cNvPr id="27" name="Inhaltsplatzhalter 26">
+          <p:cNvPr id="4" name="footer_date">
+            <a:extLst>
+              <a:ext uri="{FF2B5EF4-FFF2-40B4-BE49-F238E27FC236}">
+                <a16:creationId xmlns:a16="http://schemas.microsoft.com/office/drawing/2014/main" id="{4091CEBF-0315-0376-AECC-72B522000048}"/>
+              </a:ext>
+            </a:extLst>
+          </p:cNvPr>
+          <p:cNvSpPr>
+            <a:spLocks noGrp="1"/>
+          </p:cNvSpPr>
+          <p:nvPr>
+            <p:ph type="dt" sz="half" idx="15"/>
+          </p:nvPr>
+        </p:nvSpPr>
+        <p:spPr/>
+        <p:txBody>
+          <a:bodyPr/>
+          <a:lstStyle/>
+          <a:p>
+            <a:pPr indent="-468000"/>
+            <a:fld id="{84284A58-3EB3-4F57-9112-3DEC02019146}" type="datetime1">
+              <a:rPr lang="de-DE" smtClean="0"/>
+              <a:t>22.06.2026</a:t>
+            </a:fld>
+            <a:endParaRPr lang="de-DE" dirty="0"/>
+          </a:p>
+        </p:txBody>
+      </p:sp>
+      <p:sp>
+        <p:nvSpPr>
+          <p:cNvPr id="6" name="footer_source">
+            <a:extLst>
+              <a:ext uri="{FF2B5EF4-FFF2-40B4-BE49-F238E27FC236}">
+                <a16:creationId xmlns:a16="http://schemas.microsoft.com/office/drawing/2014/main" id="{444FF8FF-43AA-977F-26BD-15CCF4FAB847}"/>
+              </a:ext>
+            </a:extLst>
+          </p:cNvPr>
+          <p:cNvSpPr>
+            <a:spLocks noGrp="1"/>
+          </p:cNvSpPr>
+          <p:nvPr>
+            <p:ph type="ftr" sz="quarter" idx="16"/>
+          </p:nvPr>
+        </p:nvSpPr>
+        <p:spPr/>
+        <p:txBody>
+          <a:bodyPr/>
+          <a:lstStyle/>
+          <a:p>
+            <a:pPr indent="-468000"/>
+            <a:r>
+              <a:rPr lang="de-DE" dirty="0"/>
+              <a:t>Würth Line Folienmaster</a:t>
+            </a:r>
+          </a:p>
+        </p:txBody>
+      </p:sp>
+      <p:sp>
+        <p:nvSpPr>
+          <p:cNvPr id="8" name="footer_slide_number">
+            <a:extLst>
+              <a:ext uri="{FF2B5EF4-FFF2-40B4-BE49-F238E27FC236}">
+                <a16:creationId xmlns:a16="http://schemas.microsoft.com/office/drawing/2014/main" id="{6D9836F3-62A2-3351-A51F-696852650367}"/>
+              </a:ext>
+            </a:extLst>
+          </p:cNvPr>
+          <p:cNvSpPr>
+            <a:spLocks noGrp="1"/>
+          </p:cNvSpPr>
+          <p:nvPr>
+            <p:ph type="sldNum" sz="quarter" idx="17"/>
+          </p:nvPr>
+        </p:nvSpPr>
+        <p:spPr/>
+        <p:txBody>
+          <a:bodyPr/>
+          <a:lstStyle/>
+          <a:p>
+            <a:fld id="{3CBD43C5-A65B-4791-8A9A-EB6408C246D1}" type="slidenum">
+              <a:rPr lang="de-DE" smtClean="0"/>
+              <a:pPr/>
+              <a:t>‹#›</a:t>
+            </a:fld>
+            <a:endParaRPr lang="de-DE" dirty="0"/>
+          </a:p>
+        </p:txBody>
+      </p:sp>
+      <p:sp>
+        <p:nvSpPr>
+          <p:cNvPr id="27" name="content">
             <a:extLst>
               <a:ext uri="{FF2B5EF4-FFF2-40B4-BE49-F238E27FC236}">
                 <a16:creationId xmlns:a16="http://schemas.microsoft.com/office/drawing/2014/main" id="{7D331E16-2D08-849C-B297-29B2C68773C5}"/>
@@ -3028,7 +3171,7 @@
       </p:sp>
       <p:sp>
         <p:nvSpPr>
-          <p:cNvPr id="12" name="Textplatzhalter 11">
+          <p:cNvPr id="12" name="section_label">
             <a:extLst>
               <a:ext uri="{FF2B5EF4-FFF2-40B4-BE49-F238E27FC236}">
                 <a16:creationId xmlns:a16="http://schemas.microsoft.com/office/drawing/2014/main" id="{E4BB559A-959F-E065-EED1-B99203950C30}"/>
@@ -3143,7 +3286,7 @@
       </p:sp>
       <p:sp>
         <p:nvSpPr>
-          <p:cNvPr id="16" name="Titel 15">
+          <p:cNvPr id="16" name="title">
             <a:extLst>
               <a:ext uri="{FF2B5EF4-FFF2-40B4-BE49-F238E27FC236}">
                 <a16:creationId xmlns:a16="http://schemas.microsoft.com/office/drawing/2014/main" id="{B6DFC255-7930-5C81-0D87-2A24C89824D6}"/>
@@ -3154,114 +3297,25 @@
             <a:spLocks noGrp="1"/>
           </p:cNvSpPr>
           <p:nvPr>
-            <p:ph type="title"/>
+            <p:ph type="title" hasCustomPrompt="1"/>
           </p:nvPr>
         </p:nvSpPr>
         <p:spPr bwMode="gray"/>
         <p:txBody>
-          <a:bodyPr vert="horz"/>
+          <a:bodyPr vert="horz" rIns="0"/>
           <a:lstStyle/>
           <a:p>
             <a:r>
               <a:rPr lang="de-DE" dirty="0"/>
               <a:t>Mastertitelformat bearbeiten</a:t>
             </a:r>
-          </a:p>
-        </p:txBody>
-      </p:sp>
-      <p:sp>
-        <p:nvSpPr>
-          <p:cNvPr id="4" name="Datumsplatzhalter 3">
-            <a:extLst>
-              <a:ext uri="{FF2B5EF4-FFF2-40B4-BE49-F238E27FC236}">
-                <a16:creationId xmlns:a16="http://schemas.microsoft.com/office/drawing/2014/main" id="{4091CEBF-0315-0376-AECC-72B522000048}"/>
-              </a:ext>
-            </a:extLst>
-          </p:cNvPr>
-          <p:cNvSpPr>
-            <a:spLocks noGrp="1"/>
-          </p:cNvSpPr>
-          <p:nvPr>
-            <p:ph type="dt" sz="half" idx="15"/>
-          </p:nvPr>
-        </p:nvSpPr>
-        <p:spPr/>
-        <p:txBody>
-          <a:bodyPr/>
-          <a:lstStyle/>
-          <a:p>
-            <a:pPr indent="-468000"/>
-            <a:fld id="{84284A58-3EB3-4F57-9112-3DEC02019146}" type="datetime1">
-              <a:rPr lang="de-DE" smtClean="0"/>
-              <a:t>21.06.2026</a:t>
-            </a:fld>
-            <a:endParaRPr lang="de-DE" dirty="0"/>
-          </a:p>
-        </p:txBody>
-      </p:sp>
-      <p:sp>
-        <p:nvSpPr>
-          <p:cNvPr id="6" name="Fußzeilenplatzhalter 5">
-            <a:extLst>
-              <a:ext uri="{FF2B5EF4-FFF2-40B4-BE49-F238E27FC236}">
-                <a16:creationId xmlns:a16="http://schemas.microsoft.com/office/drawing/2014/main" id="{444FF8FF-43AA-977F-26BD-15CCF4FAB847}"/>
-              </a:ext>
-            </a:extLst>
-          </p:cNvPr>
-          <p:cNvSpPr>
-            <a:spLocks noGrp="1"/>
-          </p:cNvSpPr>
-          <p:nvPr>
-            <p:ph type="ftr" sz="quarter" idx="16"/>
-          </p:nvPr>
-        </p:nvSpPr>
-        <p:spPr/>
-        <p:txBody>
-          <a:bodyPr/>
-          <a:lstStyle/>
-          <a:p>
-            <a:pPr indent="-468000"/>
-            <a:r>
-              <a:rPr lang="de-DE" dirty="0"/>
-              <a:t>Würth Line Folienmaster</a:t>
-            </a:r>
-          </a:p>
-        </p:txBody>
-      </p:sp>
-      <p:sp>
-        <p:nvSpPr>
-          <p:cNvPr id="8" name="Foliennummernplatzhalter 7">
-            <a:extLst>
-              <a:ext uri="{FF2B5EF4-FFF2-40B4-BE49-F238E27FC236}">
-                <a16:creationId xmlns:a16="http://schemas.microsoft.com/office/drawing/2014/main" id="{6D9836F3-62A2-3351-A51F-696852650367}"/>
-              </a:ext>
-            </a:extLst>
-          </p:cNvPr>
-          <p:cNvSpPr>
-            <a:spLocks noGrp="1"/>
-          </p:cNvSpPr>
-          <p:nvPr>
-            <p:ph type="sldNum" sz="quarter" idx="17"/>
-          </p:nvPr>
-        </p:nvSpPr>
-        <p:spPr/>
-        <p:txBody>
-          <a:bodyPr/>
-          <a:lstStyle/>
-          <a:p>
-            <a:fld id="{3CBD43C5-A65B-4791-8A9A-EB6408C246D1}" type="slidenum">
-              <a:rPr lang="de-DE" smtClean="0"/>
-              <a:pPr/>
-              <a:t>‹#›</a:t>
-            </a:fld>
-            <a:endParaRPr lang="de-DE" dirty="0"/>
           </a:p>
         </p:txBody>
       </p:sp>
     </p:spTree>
     <p:extLst>
       <p:ext uri="{BB962C8B-B14F-4D97-AF65-F5344CB8AC3E}">
-        <p14:creationId xmlns:p14="http://schemas.microsoft.com/office/powerpoint/2010/main" val="136395648"/>
+        <p14:creationId xmlns:p14="http://schemas.microsoft.com/office/powerpoint/2010/main" val="4174371046"/>
       </p:ext>
     </p:extLst>
   </p:cSld>
@@ -3278,7 +3332,7 @@
 
 <file path=ppt/slideLayouts/slideLayout6.xml><?xml version="1.0" encoding="utf-8"?>
 <p:sldLayout xmlns:a="http://schemas.openxmlformats.org/drawingml/2006/main" xmlns:r="http://schemas.openxmlformats.org/officeDocument/2006/relationships" xmlns:p="http://schemas.openxmlformats.org/presentationml/2006/main" preserve="1" userDrawn="1">
-  <p:cSld name="Agent 06 Comparison">
+  <p:cSld name="agent_06_two_cards">
     <p:spTree>
       <p:nvGrpSpPr>
         <p:cNvPr id="1" name=""/>
@@ -3367,23 +3421,174 @@
       </p:graphicFrame>
       <p:sp>
         <p:nvSpPr>
-          <p:cNvPr id="10" name="Textplatzhalter 9">
-            <a:extLst>
-              <a:ext uri="{FF2B5EF4-FFF2-40B4-BE49-F238E27FC236}">
-                <a16:creationId xmlns:a16="http://schemas.microsoft.com/office/drawing/2014/main" id="{CC3F866E-CB14-5126-3D67-CB00D59F0DED}"/>
-              </a:ext>
-            </a:extLst>
-          </p:cNvPr>
-          <p:cNvSpPr>
-            <a:spLocks noGrp="1"/>
-          </p:cNvSpPr>
-          <p:nvPr>
-            <p:ph type="body" sz="quarter" idx="30"/>
+          <p:cNvPr id="2" name="footer_date">
+            <a:extLst>
+              <a:ext uri="{FF2B5EF4-FFF2-40B4-BE49-F238E27FC236}">
+                <a16:creationId xmlns:a16="http://schemas.microsoft.com/office/drawing/2014/main" id="{0BDBD9B5-4CAD-5703-8D7C-2B73FD293BB6}"/>
+              </a:ext>
+            </a:extLst>
+          </p:cNvPr>
+          <p:cNvSpPr>
+            <a:spLocks noGrp="1"/>
+          </p:cNvSpPr>
+          <p:nvPr>
+            <p:ph type="dt" sz="half" idx="37"/>
+          </p:nvPr>
+        </p:nvSpPr>
+        <p:spPr/>
+        <p:txBody>
+          <a:bodyPr/>
+          <a:lstStyle/>
+          <a:p>
+            <a:pPr indent="-468000"/>
+            <a:fld id="{84284A58-3EB3-4F57-9112-3DEC02019146}" type="datetime1">
+              <a:rPr lang="de-DE" smtClean="0"/>
+              <a:t>22.06.2026</a:t>
+            </a:fld>
+            <a:endParaRPr lang="de-DE" dirty="0"/>
+          </a:p>
+        </p:txBody>
+      </p:sp>
+      <p:sp>
+        <p:nvSpPr>
+          <p:cNvPr id="3" name="footer_source">
+            <a:extLst>
+              <a:ext uri="{FF2B5EF4-FFF2-40B4-BE49-F238E27FC236}">
+                <a16:creationId xmlns:a16="http://schemas.microsoft.com/office/drawing/2014/main" id="{BBBDC7C5-F86B-B8CC-DA2D-196F395E62B4}"/>
+              </a:ext>
+            </a:extLst>
+          </p:cNvPr>
+          <p:cNvSpPr>
+            <a:spLocks noGrp="1"/>
+          </p:cNvSpPr>
+          <p:nvPr>
+            <p:ph type="ftr" sz="quarter" idx="38"/>
+          </p:nvPr>
+        </p:nvSpPr>
+        <p:spPr/>
+        <p:txBody>
+          <a:bodyPr/>
+          <a:lstStyle/>
+          <a:p>
+            <a:pPr indent="-468000"/>
+            <a:r>
+              <a:rPr lang="de-DE" dirty="0"/>
+              <a:t>Würth Line Folienmaster</a:t>
+            </a:r>
+          </a:p>
+        </p:txBody>
+      </p:sp>
+      <p:sp>
+        <p:nvSpPr>
+          <p:cNvPr id="4" name="footer_slide_number">
+            <a:extLst>
+              <a:ext uri="{FF2B5EF4-FFF2-40B4-BE49-F238E27FC236}">
+                <a16:creationId xmlns:a16="http://schemas.microsoft.com/office/drawing/2014/main" id="{789DD86D-1C38-BC91-5F7D-05E857D86C5F}"/>
+              </a:ext>
+            </a:extLst>
+          </p:cNvPr>
+          <p:cNvSpPr>
+            <a:spLocks noGrp="1"/>
+          </p:cNvSpPr>
+          <p:nvPr>
+            <p:ph type="sldNum" sz="quarter" idx="39"/>
+          </p:nvPr>
+        </p:nvSpPr>
+        <p:spPr/>
+        <p:txBody>
+          <a:bodyPr/>
+          <a:lstStyle/>
+          <a:p>
+            <a:fld id="{3CBD43C5-A65B-4791-8A9A-EB6408C246D1}" type="slidenum">
+              <a:rPr lang="de-DE" smtClean="0"/>
+              <a:pPr/>
+              <a:t>‹#›</a:t>
+            </a:fld>
+            <a:endParaRPr lang="de-DE" dirty="0"/>
+          </a:p>
+        </p:txBody>
+      </p:sp>
+      <p:sp>
+        <p:nvSpPr>
+          <p:cNvPr id="11" name="card_2_content">
+            <a:extLst>
+              <a:ext uri="{FF2B5EF4-FFF2-40B4-BE49-F238E27FC236}">
+                <a16:creationId xmlns:a16="http://schemas.microsoft.com/office/drawing/2014/main" id="{CB56D043-329D-D7A7-5B4E-2A9DEE147E64}"/>
+              </a:ext>
+            </a:extLst>
+          </p:cNvPr>
+          <p:cNvSpPr>
+            <a:spLocks noGrp="1"/>
+          </p:cNvSpPr>
+          <p:nvPr>
+            <p:ph sz="quarter" idx="36"/>
           </p:nvPr>
         </p:nvSpPr>
         <p:spPr bwMode="gray">
           <a:xfrm>
-            <a:off x="358775" y="1230109"/>
+            <a:off x="4698000" y="1969770"/>
+            <a:ext cx="4087225" cy="2750400"/>
+          </a:xfrm>
+        </p:spPr>
+        <p:txBody>
+          <a:bodyPr tIns="0"/>
+          <a:lstStyle/>
+          <a:p>
+            <a:pPr lvl="0"/>
+            <a:r>
+              <a:rPr lang="de-DE" dirty="0"/>
+              <a:t>Mastertextformat bearbeiten</a:t>
+            </a:r>
+          </a:p>
+          <a:p>
+            <a:pPr lvl="1"/>
+            <a:r>
+              <a:rPr lang="de-DE" dirty="0"/>
+              <a:t>Zweite Ebene</a:t>
+            </a:r>
+          </a:p>
+          <a:p>
+            <a:pPr lvl="2"/>
+            <a:r>
+              <a:rPr lang="de-DE" dirty="0"/>
+              <a:t>Dritte Ebene</a:t>
+            </a:r>
+          </a:p>
+          <a:p>
+            <a:pPr lvl="3"/>
+            <a:r>
+              <a:rPr lang="de-DE" dirty="0"/>
+              <a:t>Vierte Ebene</a:t>
+            </a:r>
+          </a:p>
+          <a:p>
+            <a:pPr lvl="4"/>
+            <a:r>
+              <a:rPr lang="de-DE" dirty="0"/>
+              <a:t>Fünfte Ebene</a:t>
+            </a:r>
+          </a:p>
+        </p:txBody>
+      </p:sp>
+      <p:sp>
+        <p:nvSpPr>
+          <p:cNvPr id="15" name="card_2_title">
+            <a:extLst>
+              <a:ext uri="{FF2B5EF4-FFF2-40B4-BE49-F238E27FC236}">
+                <a16:creationId xmlns:a16="http://schemas.microsoft.com/office/drawing/2014/main" id="{EE60DF5C-5A64-E232-22CA-757A6DBB065F}"/>
+              </a:ext>
+            </a:extLst>
+          </p:cNvPr>
+          <p:cNvSpPr>
+            <a:spLocks noGrp="1"/>
+          </p:cNvSpPr>
+          <p:nvPr>
+            <p:ph type="body" sz="quarter" idx="31"/>
+          </p:nvPr>
+        </p:nvSpPr>
+        <p:spPr bwMode="gray">
+          <a:xfrm>
+            <a:off x="4698000" y="1230109"/>
             <a:ext cx="4087225" cy="657744"/>
           </a:xfrm>
         </p:spPr>
@@ -3419,7 +3624,121 @@
       </p:sp>
       <p:sp>
         <p:nvSpPr>
-          <p:cNvPr id="12" name="Textplatzhalter 11">
+          <p:cNvPr id="27" name="card_1_content">
+            <a:extLst>
+              <a:ext uri="{FF2B5EF4-FFF2-40B4-BE49-F238E27FC236}">
+                <a16:creationId xmlns:a16="http://schemas.microsoft.com/office/drawing/2014/main" id="{7D331E16-2D08-849C-B297-29B2C68773C5}"/>
+              </a:ext>
+            </a:extLst>
+          </p:cNvPr>
+          <p:cNvSpPr>
+            <a:spLocks noGrp="1"/>
+          </p:cNvSpPr>
+          <p:nvPr>
+            <p:ph sz="quarter" idx="14"/>
+          </p:nvPr>
+        </p:nvSpPr>
+        <p:spPr bwMode="gray">
+          <a:xfrm>
+            <a:off x="358775" y="1969770"/>
+            <a:ext cx="4087225" cy="2750400"/>
+          </a:xfrm>
+        </p:spPr>
+        <p:txBody>
+          <a:bodyPr tIns="0"/>
+          <a:lstStyle/>
+          <a:p>
+            <a:pPr lvl="0"/>
+            <a:r>
+              <a:rPr lang="de-DE" dirty="0"/>
+              <a:t>Mastertextformat bearbeiten</a:t>
+            </a:r>
+          </a:p>
+          <a:p>
+            <a:pPr lvl="1"/>
+            <a:r>
+              <a:rPr lang="de-DE" dirty="0"/>
+              <a:t>Zweite Ebene</a:t>
+            </a:r>
+          </a:p>
+          <a:p>
+            <a:pPr lvl="2"/>
+            <a:r>
+              <a:rPr lang="de-DE" dirty="0"/>
+              <a:t>Dritte Ebene</a:t>
+            </a:r>
+          </a:p>
+          <a:p>
+            <a:pPr lvl="3"/>
+            <a:r>
+              <a:rPr lang="de-DE" dirty="0"/>
+              <a:t>Vierte Ebene</a:t>
+            </a:r>
+          </a:p>
+          <a:p>
+            <a:pPr lvl="4"/>
+            <a:r>
+              <a:rPr lang="de-DE" dirty="0"/>
+              <a:t>Fünfte Ebene</a:t>
+            </a:r>
+          </a:p>
+        </p:txBody>
+      </p:sp>
+      <p:sp>
+        <p:nvSpPr>
+          <p:cNvPr id="10" name="card_1_title">
+            <a:extLst>
+              <a:ext uri="{FF2B5EF4-FFF2-40B4-BE49-F238E27FC236}">
+                <a16:creationId xmlns:a16="http://schemas.microsoft.com/office/drawing/2014/main" id="{CC3F866E-CB14-5126-3D67-CB00D59F0DED}"/>
+              </a:ext>
+            </a:extLst>
+          </p:cNvPr>
+          <p:cNvSpPr>
+            <a:spLocks noGrp="1"/>
+          </p:cNvSpPr>
+          <p:nvPr>
+            <p:ph type="body" sz="quarter" idx="30"/>
+          </p:nvPr>
+        </p:nvSpPr>
+        <p:spPr bwMode="gray">
+          <a:xfrm>
+            <a:off x="358775" y="1230109"/>
+            <a:ext cx="4087225" cy="657744"/>
+          </a:xfrm>
+        </p:spPr>
+        <p:txBody>
+          <a:bodyPr anchor="b" anchorCtr="0"/>
+          <a:lstStyle>
+            <a:lvl1pPr>
+              <a:defRPr sz="1900">
+                <a:latin typeface="Wuerth Bold" panose="020B0802020204020204" pitchFamily="34" charset="0"/>
+              </a:defRPr>
+            </a:lvl1pPr>
+            <a:lvl2pPr>
+              <a:defRPr sz="2000"/>
+            </a:lvl2pPr>
+            <a:lvl3pPr>
+              <a:defRPr sz="2000"/>
+            </a:lvl3pPr>
+            <a:lvl4pPr>
+              <a:defRPr sz="1800"/>
+            </a:lvl4pPr>
+            <a:lvl5pPr>
+              <a:defRPr sz="1800"/>
+            </a:lvl5pPr>
+          </a:lstStyle>
+          <a:p>
+            <a:pPr lvl="0"/>
+            <a:r>
+              <a:rPr lang="de-DE" dirty="0"/>
+              <a:t>Mastertextformat bearbeiten</a:t>
+            </a:r>
+          </a:p>
+        </p:txBody>
+      </p:sp>
+      <p:sp>
+        <p:nvSpPr>
+          <p:cNvPr id="12" name="section_label">
             <a:extLst>
               <a:ext uri="{FF2B5EF4-FFF2-40B4-BE49-F238E27FC236}">
                 <a16:creationId xmlns:a16="http://schemas.microsoft.com/office/drawing/2014/main" id="{E4BB559A-959F-E065-EED1-B99203950C30}"/>
@@ -3534,294 +3853,29 @@
       </p:sp>
       <p:sp>
         <p:nvSpPr>
-          <p:cNvPr id="27" name="Inhaltsplatzhalter 26">
-            <a:extLst>
-              <a:ext uri="{FF2B5EF4-FFF2-40B4-BE49-F238E27FC236}">
-                <a16:creationId xmlns:a16="http://schemas.microsoft.com/office/drawing/2014/main" id="{7D331E16-2D08-849C-B297-29B2C68773C5}"/>
-              </a:ext>
-            </a:extLst>
-          </p:cNvPr>
-          <p:cNvSpPr>
-            <a:spLocks noGrp="1"/>
-          </p:cNvSpPr>
-          <p:nvPr>
-            <p:ph sz="quarter" idx="14"/>
-          </p:nvPr>
-        </p:nvSpPr>
-        <p:spPr bwMode="gray">
-          <a:xfrm>
-            <a:off x="358775" y="1969770"/>
-            <a:ext cx="4087225" cy="2750400"/>
-          </a:xfrm>
-        </p:spPr>
-        <p:txBody>
-          <a:bodyPr tIns="0"/>
+          <p:cNvPr id="24" name="title">
+            <a:extLst>
+              <a:ext uri="{FF2B5EF4-FFF2-40B4-BE49-F238E27FC236}">
+                <a16:creationId xmlns:a16="http://schemas.microsoft.com/office/drawing/2014/main" id="{D260FF38-23F0-A4B9-63CE-14126812B0FA}"/>
+              </a:ext>
+            </a:extLst>
+          </p:cNvPr>
+          <p:cNvSpPr>
+            <a:spLocks noGrp="1"/>
+          </p:cNvSpPr>
+          <p:nvPr>
+            <p:ph type="title" hasCustomPrompt="1"/>
+          </p:nvPr>
+        </p:nvSpPr>
+        <p:spPr bwMode="gray"/>
+        <p:txBody>
+          <a:bodyPr vert="horz" rIns="0"/>
           <a:lstStyle/>
           <a:p>
-            <a:pPr lvl="0"/>
-            <a:r>
-              <a:rPr lang="de-DE" dirty="0"/>
-              <a:t>Mastertextformat bearbeiten</a:t>
-            </a:r>
-          </a:p>
-          <a:p>
-            <a:pPr lvl="1"/>
-            <a:r>
-              <a:rPr lang="de-DE" dirty="0"/>
-              <a:t>Zweite Ebene</a:t>
-            </a:r>
-          </a:p>
-          <a:p>
-            <a:pPr lvl="2"/>
-            <a:r>
-              <a:rPr lang="de-DE" dirty="0"/>
-              <a:t>Dritte Ebene</a:t>
-            </a:r>
-          </a:p>
-          <a:p>
-            <a:pPr lvl="3"/>
-            <a:r>
-              <a:rPr lang="de-DE" dirty="0"/>
-              <a:t>Vierte Ebene</a:t>
-            </a:r>
-          </a:p>
-          <a:p>
-            <a:pPr lvl="4"/>
-            <a:r>
-              <a:rPr lang="de-DE" dirty="0"/>
-              <a:t>Fünfte Ebene</a:t>
-            </a:r>
-          </a:p>
-        </p:txBody>
-      </p:sp>
-      <p:sp>
-        <p:nvSpPr>
-          <p:cNvPr id="15" name="Textplatzhalter 9">
-            <a:extLst>
-              <a:ext uri="{FF2B5EF4-FFF2-40B4-BE49-F238E27FC236}">
-                <a16:creationId xmlns:a16="http://schemas.microsoft.com/office/drawing/2014/main" id="{EE60DF5C-5A64-E232-22CA-757A6DBB065F}"/>
-              </a:ext>
-            </a:extLst>
-          </p:cNvPr>
-          <p:cNvSpPr>
-            <a:spLocks noGrp="1"/>
-          </p:cNvSpPr>
-          <p:nvPr>
-            <p:ph type="body" sz="quarter" idx="31"/>
-          </p:nvPr>
-        </p:nvSpPr>
-        <p:spPr bwMode="gray">
-          <a:xfrm>
-            <a:off x="4698000" y="1230109"/>
-            <a:ext cx="4087225" cy="657744"/>
-          </a:xfrm>
-        </p:spPr>
-        <p:txBody>
-          <a:bodyPr anchor="b" anchorCtr="0"/>
-          <a:lstStyle>
-            <a:lvl1pPr>
-              <a:defRPr sz="1900">
-                <a:latin typeface="Wuerth Bold" panose="020B0802020204020204" pitchFamily="34" charset="0"/>
-              </a:defRPr>
-            </a:lvl1pPr>
-            <a:lvl2pPr>
-              <a:defRPr sz="2000"/>
-            </a:lvl2pPr>
-            <a:lvl3pPr>
-              <a:defRPr sz="2000"/>
-            </a:lvl3pPr>
-            <a:lvl4pPr>
-              <a:defRPr sz="1800"/>
-            </a:lvl4pPr>
-            <a:lvl5pPr>
-              <a:defRPr sz="1800"/>
-            </a:lvl5pPr>
-          </a:lstStyle>
-          <a:p>
-            <a:pPr lvl="0"/>
-            <a:r>
-              <a:rPr lang="de-DE" dirty="0"/>
-              <a:t>Mastertextformat bearbeiten</a:t>
-            </a:r>
-          </a:p>
-        </p:txBody>
-      </p:sp>
-      <p:sp>
-        <p:nvSpPr>
-          <p:cNvPr id="11" name="Inhaltsplatzhalter 9">
-            <a:extLst>
-              <a:ext uri="{FF2B5EF4-FFF2-40B4-BE49-F238E27FC236}">
-                <a16:creationId xmlns:a16="http://schemas.microsoft.com/office/drawing/2014/main" id="{CB56D043-329D-D7A7-5B4E-2A9DEE147E64}"/>
-              </a:ext>
-            </a:extLst>
-          </p:cNvPr>
-          <p:cNvSpPr>
-            <a:spLocks noGrp="1"/>
-          </p:cNvSpPr>
-          <p:nvPr>
-            <p:ph sz="quarter" idx="36"/>
-          </p:nvPr>
-        </p:nvSpPr>
-        <p:spPr bwMode="gray">
-          <a:xfrm>
-            <a:off x="4698000" y="1969770"/>
-            <a:ext cx="4087225" cy="2750400"/>
-          </a:xfrm>
-        </p:spPr>
-        <p:txBody>
-          <a:bodyPr tIns="0"/>
-          <a:lstStyle/>
-          <a:p>
-            <a:pPr lvl="0"/>
-            <a:r>
-              <a:rPr lang="de-DE" dirty="0"/>
-              <a:t>Mastertextformat bearbeiten</a:t>
-            </a:r>
-          </a:p>
-          <a:p>
-            <a:pPr lvl="1"/>
-            <a:r>
-              <a:rPr lang="de-DE" dirty="0"/>
-              <a:t>Zweite Ebene</a:t>
-            </a:r>
-          </a:p>
-          <a:p>
-            <a:pPr lvl="2"/>
-            <a:r>
-              <a:rPr lang="de-DE" dirty="0"/>
-              <a:t>Dritte Ebene</a:t>
-            </a:r>
-          </a:p>
-          <a:p>
-            <a:pPr lvl="3"/>
-            <a:r>
-              <a:rPr lang="de-DE" dirty="0"/>
-              <a:t>Vierte Ebene</a:t>
-            </a:r>
-          </a:p>
-          <a:p>
-            <a:pPr lvl="4"/>
-            <a:r>
-              <a:rPr lang="de-DE" dirty="0"/>
-              <a:t>Fünfte Ebene</a:t>
-            </a:r>
-          </a:p>
-        </p:txBody>
-      </p:sp>
-      <p:sp>
-        <p:nvSpPr>
-          <p:cNvPr id="24" name="Titel 23">
-            <a:extLst>
-              <a:ext uri="{FF2B5EF4-FFF2-40B4-BE49-F238E27FC236}">
-                <a16:creationId xmlns:a16="http://schemas.microsoft.com/office/drawing/2014/main" id="{D260FF38-23F0-A4B9-63CE-14126812B0FA}"/>
-              </a:ext>
-            </a:extLst>
-          </p:cNvPr>
-          <p:cNvSpPr>
-            <a:spLocks noGrp="1"/>
-          </p:cNvSpPr>
-          <p:nvPr>
-            <p:ph type="title"/>
-          </p:nvPr>
-        </p:nvSpPr>
-        <p:spPr bwMode="gray"/>
-        <p:txBody>
-          <a:bodyPr vert="horz"/>
-          <a:lstStyle/>
-          <a:p>
             <a:r>
               <a:rPr lang="de-DE" dirty="0"/>
               <a:t>Mastertitelformat bearbeiten</a:t>
             </a:r>
-          </a:p>
-        </p:txBody>
-      </p:sp>
-      <p:sp>
-        <p:nvSpPr>
-          <p:cNvPr id="2" name="Datumsplatzhalter 1">
-            <a:extLst>
-              <a:ext uri="{FF2B5EF4-FFF2-40B4-BE49-F238E27FC236}">
-                <a16:creationId xmlns:a16="http://schemas.microsoft.com/office/drawing/2014/main" id="{0BDBD9B5-4CAD-5703-8D7C-2B73FD293BB6}"/>
-              </a:ext>
-            </a:extLst>
-          </p:cNvPr>
-          <p:cNvSpPr>
-            <a:spLocks noGrp="1"/>
-          </p:cNvSpPr>
-          <p:nvPr>
-            <p:ph type="dt" sz="half" idx="37"/>
-          </p:nvPr>
-        </p:nvSpPr>
-        <p:spPr/>
-        <p:txBody>
-          <a:bodyPr/>
-          <a:lstStyle/>
-          <a:p>
-            <a:pPr indent="-468000"/>
-            <a:fld id="{84284A58-3EB3-4F57-9112-3DEC02019146}" type="datetime1">
-              <a:rPr lang="de-DE" smtClean="0"/>
-              <a:t>21.06.2026</a:t>
-            </a:fld>
-            <a:endParaRPr lang="de-DE" dirty="0"/>
-          </a:p>
-        </p:txBody>
-      </p:sp>
-      <p:sp>
-        <p:nvSpPr>
-          <p:cNvPr id="3" name="Fußzeilenplatzhalter 2">
-            <a:extLst>
-              <a:ext uri="{FF2B5EF4-FFF2-40B4-BE49-F238E27FC236}">
-                <a16:creationId xmlns:a16="http://schemas.microsoft.com/office/drawing/2014/main" id="{BBBDC7C5-F86B-B8CC-DA2D-196F395E62B4}"/>
-              </a:ext>
-            </a:extLst>
-          </p:cNvPr>
-          <p:cNvSpPr>
-            <a:spLocks noGrp="1"/>
-          </p:cNvSpPr>
-          <p:nvPr>
-            <p:ph type="ftr" sz="quarter" idx="38"/>
-          </p:nvPr>
-        </p:nvSpPr>
-        <p:spPr/>
-        <p:txBody>
-          <a:bodyPr/>
-          <a:lstStyle/>
-          <a:p>
-            <a:pPr indent="-468000"/>
-            <a:r>
-              <a:rPr lang="de-DE" dirty="0"/>
-              <a:t>Würth Line Folienmaster</a:t>
-            </a:r>
-          </a:p>
-        </p:txBody>
-      </p:sp>
-      <p:sp>
-        <p:nvSpPr>
-          <p:cNvPr id="4" name="Foliennummernplatzhalter 3">
-            <a:extLst>
-              <a:ext uri="{FF2B5EF4-FFF2-40B4-BE49-F238E27FC236}">
-                <a16:creationId xmlns:a16="http://schemas.microsoft.com/office/drawing/2014/main" id="{789DD86D-1C38-BC91-5F7D-05E857D86C5F}"/>
-              </a:ext>
-            </a:extLst>
-          </p:cNvPr>
-          <p:cNvSpPr>
-            <a:spLocks noGrp="1"/>
-          </p:cNvSpPr>
-          <p:nvPr>
-            <p:ph type="sldNum" sz="quarter" idx="39"/>
-          </p:nvPr>
-        </p:nvSpPr>
-        <p:spPr/>
-        <p:txBody>
-          <a:bodyPr/>
-          <a:lstStyle/>
-          <a:p>
-            <a:fld id="{3CBD43C5-A65B-4791-8A9A-EB6408C246D1}" type="slidenum">
-              <a:rPr lang="de-DE" smtClean="0"/>
-              <a:pPr/>
-              <a:t>‹#›</a:t>
-            </a:fld>
-            <a:endParaRPr lang="de-DE" dirty="0"/>
           </a:p>
         </p:txBody>
       </p:sp>
@@ -3856,7 +3910,7 @@
 
 <file path=ppt/slideLayouts/slideLayout7.xml><?xml version="1.0" encoding="utf-8"?>
 <p:sldLayout xmlns:a="http://schemas.openxmlformats.org/drawingml/2006/main" xmlns:r="http://schemas.openxmlformats.org/officeDocument/2006/relationships" xmlns:p="http://schemas.openxmlformats.org/presentationml/2006/main" preserve="1" userDrawn="1">
-  <p:cSld name="Agent 07 Caveats And Sources">
+  <p:cSld name="agent_07_caveats_sources">
     <p:spTree>
       <p:nvGrpSpPr>
         <p:cNvPr id="1" name=""/>
@@ -3889,7 +3943,7 @@
             </p:custDataLst>
             <p:extLst>
               <p:ext uri="{D42A27DB-BD31-4B8C-83A1-F6EECF244321}">
-                <p14:modId xmlns:p14="http://schemas.microsoft.com/office/powerpoint/2010/main" val="2848507216"/>
+                <p14:modId xmlns:p14="http://schemas.microsoft.com/office/powerpoint/2010/main" val="3376174090"/>
               </p:ext>
             </p:extLst>
           </p:nvPr>
@@ -3945,7 +3999,96 @@
       </p:graphicFrame>
       <p:sp>
         <p:nvSpPr>
-          <p:cNvPr id="27" name="Inhaltsplatzhalter 26">
+          <p:cNvPr id="4" name="footer_date">
+            <a:extLst>
+              <a:ext uri="{FF2B5EF4-FFF2-40B4-BE49-F238E27FC236}">
+                <a16:creationId xmlns:a16="http://schemas.microsoft.com/office/drawing/2014/main" id="{4091CEBF-0315-0376-AECC-72B522000048}"/>
+              </a:ext>
+            </a:extLst>
+          </p:cNvPr>
+          <p:cNvSpPr>
+            <a:spLocks noGrp="1"/>
+          </p:cNvSpPr>
+          <p:nvPr>
+            <p:ph type="dt" sz="half" idx="15"/>
+          </p:nvPr>
+        </p:nvSpPr>
+        <p:spPr/>
+        <p:txBody>
+          <a:bodyPr/>
+          <a:lstStyle/>
+          <a:p>
+            <a:pPr indent="-468000"/>
+            <a:fld id="{84284A58-3EB3-4F57-9112-3DEC02019146}" type="datetime1">
+              <a:rPr lang="de-DE" smtClean="0"/>
+              <a:t>22.06.2026</a:t>
+            </a:fld>
+            <a:endParaRPr lang="de-DE" dirty="0"/>
+          </a:p>
+        </p:txBody>
+      </p:sp>
+      <p:sp>
+        <p:nvSpPr>
+          <p:cNvPr id="6" name="footer_source">
+            <a:extLst>
+              <a:ext uri="{FF2B5EF4-FFF2-40B4-BE49-F238E27FC236}">
+                <a16:creationId xmlns:a16="http://schemas.microsoft.com/office/drawing/2014/main" id="{444FF8FF-43AA-977F-26BD-15CCF4FAB847}"/>
+              </a:ext>
+            </a:extLst>
+          </p:cNvPr>
+          <p:cNvSpPr>
+            <a:spLocks noGrp="1"/>
+          </p:cNvSpPr>
+          <p:nvPr>
+            <p:ph type="ftr" sz="quarter" idx="16"/>
+          </p:nvPr>
+        </p:nvSpPr>
+        <p:spPr/>
+        <p:txBody>
+          <a:bodyPr/>
+          <a:lstStyle/>
+          <a:p>
+            <a:pPr indent="-468000"/>
+            <a:r>
+              <a:rPr lang="de-DE" dirty="0"/>
+              <a:t>Würth Line Folienmaster</a:t>
+            </a:r>
+          </a:p>
+        </p:txBody>
+      </p:sp>
+      <p:sp>
+        <p:nvSpPr>
+          <p:cNvPr id="8" name="footer_slide_number">
+            <a:extLst>
+              <a:ext uri="{FF2B5EF4-FFF2-40B4-BE49-F238E27FC236}">
+                <a16:creationId xmlns:a16="http://schemas.microsoft.com/office/drawing/2014/main" id="{6D9836F3-62A2-3351-A51F-696852650367}"/>
+              </a:ext>
+            </a:extLst>
+          </p:cNvPr>
+          <p:cNvSpPr>
+            <a:spLocks noGrp="1"/>
+          </p:cNvSpPr>
+          <p:nvPr>
+            <p:ph type="sldNum" sz="quarter" idx="17"/>
+          </p:nvPr>
+        </p:nvSpPr>
+        <p:spPr/>
+        <p:txBody>
+          <a:bodyPr/>
+          <a:lstStyle/>
+          <a:p>
+            <a:fld id="{3CBD43C5-A65B-4791-8A9A-EB6408C246D1}" type="slidenum">
+              <a:rPr lang="de-DE" smtClean="0"/>
+              <a:pPr/>
+              <a:t>‹#›</a:t>
+            </a:fld>
+            <a:endParaRPr lang="de-DE" dirty="0"/>
+          </a:p>
+        </p:txBody>
+      </p:sp>
+      <p:sp>
+        <p:nvSpPr>
+          <p:cNvPr id="27" name="content">
             <a:extLst>
               <a:ext uri="{FF2B5EF4-FFF2-40B4-BE49-F238E27FC236}">
                 <a16:creationId xmlns:a16="http://schemas.microsoft.com/office/drawing/2014/main" id="{7D331E16-2D08-849C-B297-29B2C68773C5}"/>
@@ -4017,7 +4160,7 @@
       </p:sp>
       <p:sp>
         <p:nvSpPr>
-          <p:cNvPr id="12" name="Textplatzhalter 11">
+          <p:cNvPr id="12" name="section_label">
             <a:extLst>
               <a:ext uri="{FF2B5EF4-FFF2-40B4-BE49-F238E27FC236}">
                 <a16:creationId xmlns:a16="http://schemas.microsoft.com/office/drawing/2014/main" id="{E4BB559A-959F-E065-EED1-B99203950C30}"/>
@@ -4132,7 +4275,7 @@
       </p:sp>
       <p:sp>
         <p:nvSpPr>
-          <p:cNvPr id="16" name="Titel 15">
+          <p:cNvPr id="16" name="title">
             <a:extLst>
               <a:ext uri="{FF2B5EF4-FFF2-40B4-BE49-F238E27FC236}">
                 <a16:creationId xmlns:a16="http://schemas.microsoft.com/office/drawing/2014/main" id="{B6DFC255-7930-5C81-0D87-2A24C89824D6}"/>
@@ -4143,114 +4286,25 @@
             <a:spLocks noGrp="1"/>
           </p:cNvSpPr>
           <p:nvPr>
-            <p:ph type="title"/>
+            <p:ph type="title" hasCustomPrompt="1"/>
           </p:nvPr>
         </p:nvSpPr>
         <p:spPr bwMode="gray"/>
         <p:txBody>
-          <a:bodyPr vert="horz"/>
+          <a:bodyPr vert="horz" rIns="0"/>
           <a:lstStyle/>
           <a:p>
             <a:r>
               <a:rPr lang="de-DE" dirty="0"/>
               <a:t>Mastertitelformat bearbeiten</a:t>
             </a:r>
-          </a:p>
-        </p:txBody>
-      </p:sp>
-      <p:sp>
-        <p:nvSpPr>
-          <p:cNvPr id="4" name="Datumsplatzhalter 3">
-            <a:extLst>
-              <a:ext uri="{FF2B5EF4-FFF2-40B4-BE49-F238E27FC236}">
-                <a16:creationId xmlns:a16="http://schemas.microsoft.com/office/drawing/2014/main" id="{4091CEBF-0315-0376-AECC-72B522000048}"/>
-              </a:ext>
-            </a:extLst>
-          </p:cNvPr>
-          <p:cNvSpPr>
-            <a:spLocks noGrp="1"/>
-          </p:cNvSpPr>
-          <p:nvPr>
-            <p:ph type="dt" sz="half" idx="15"/>
-          </p:nvPr>
-        </p:nvSpPr>
-        <p:spPr/>
-        <p:txBody>
-          <a:bodyPr/>
-          <a:lstStyle/>
-          <a:p>
-            <a:pPr indent="-468000"/>
-            <a:fld id="{84284A58-3EB3-4F57-9112-3DEC02019146}" type="datetime1">
-              <a:rPr lang="de-DE" smtClean="0"/>
-              <a:t>21.06.2026</a:t>
-            </a:fld>
-            <a:endParaRPr lang="de-DE" dirty="0"/>
-          </a:p>
-        </p:txBody>
-      </p:sp>
-      <p:sp>
-        <p:nvSpPr>
-          <p:cNvPr id="6" name="Fußzeilenplatzhalter 5">
-            <a:extLst>
-              <a:ext uri="{FF2B5EF4-FFF2-40B4-BE49-F238E27FC236}">
-                <a16:creationId xmlns:a16="http://schemas.microsoft.com/office/drawing/2014/main" id="{444FF8FF-43AA-977F-26BD-15CCF4FAB847}"/>
-              </a:ext>
-            </a:extLst>
-          </p:cNvPr>
-          <p:cNvSpPr>
-            <a:spLocks noGrp="1"/>
-          </p:cNvSpPr>
-          <p:nvPr>
-            <p:ph type="ftr" sz="quarter" idx="16"/>
-          </p:nvPr>
-        </p:nvSpPr>
-        <p:spPr/>
-        <p:txBody>
-          <a:bodyPr/>
-          <a:lstStyle/>
-          <a:p>
-            <a:pPr indent="-468000"/>
-            <a:r>
-              <a:rPr lang="de-DE" dirty="0"/>
-              <a:t>Würth Line Folienmaster</a:t>
-            </a:r>
-          </a:p>
-        </p:txBody>
-      </p:sp>
-      <p:sp>
-        <p:nvSpPr>
-          <p:cNvPr id="8" name="Foliennummernplatzhalter 7">
-            <a:extLst>
-              <a:ext uri="{FF2B5EF4-FFF2-40B4-BE49-F238E27FC236}">
-                <a16:creationId xmlns:a16="http://schemas.microsoft.com/office/drawing/2014/main" id="{6D9836F3-62A2-3351-A51F-696852650367}"/>
-              </a:ext>
-            </a:extLst>
-          </p:cNvPr>
-          <p:cNvSpPr>
-            <a:spLocks noGrp="1"/>
-          </p:cNvSpPr>
-          <p:nvPr>
-            <p:ph type="sldNum" sz="quarter" idx="17"/>
-          </p:nvPr>
-        </p:nvSpPr>
-        <p:spPr/>
-        <p:txBody>
-          <a:bodyPr/>
-          <a:lstStyle/>
-          <a:p>
-            <a:fld id="{3CBD43C5-A65B-4791-8A9A-EB6408C246D1}" type="slidenum">
-              <a:rPr lang="de-DE" smtClean="0"/>
-              <a:pPr/>
-              <a:t>‹#›</a:t>
-            </a:fld>
-            <a:endParaRPr lang="de-DE" dirty="0"/>
           </a:p>
         </p:txBody>
       </p:sp>
     </p:spTree>
     <p:extLst>
       <p:ext uri="{BB962C8B-B14F-4D97-AF65-F5344CB8AC3E}">
-        <p14:creationId xmlns:p14="http://schemas.microsoft.com/office/powerpoint/2010/main" val="1402562085"/>
+        <p14:creationId xmlns:p14="http://schemas.microsoft.com/office/powerpoint/2010/main" val="4147896511"/>
       </p:ext>
     </p:extLst>
   </p:cSld>
@@ -4267,7 +4321,7 @@
 
 <file path=ppt/slideLayouts/slideLayout8.xml><?xml version="1.0" encoding="utf-8"?>
 <p:sldLayout xmlns:a="http://schemas.openxmlformats.org/drawingml/2006/main" xmlns:r="http://schemas.openxmlformats.org/officeDocument/2006/relationships" xmlns:p="http://schemas.openxmlformats.org/presentationml/2006/main" preserve="1" userDrawn="1">
-  <p:cSld name="Agent 08 Appendix Metadata">
+  <p:cSld name="agent_08_appendix_metadata">
     <p:spTree>
       <p:nvGrpSpPr>
         <p:cNvPr id="1" name=""/>
@@ -4300,7 +4354,7 @@
             </p:custDataLst>
             <p:extLst>
               <p:ext uri="{D42A27DB-BD31-4B8C-83A1-F6EECF244321}">
-                <p14:modId xmlns:p14="http://schemas.microsoft.com/office/powerpoint/2010/main" val="2848507216"/>
+                <p14:modId xmlns:p14="http://schemas.microsoft.com/office/powerpoint/2010/main" val="3376174090"/>
               </p:ext>
             </p:extLst>
           </p:nvPr>
@@ -4356,7 +4410,96 @@
       </p:graphicFrame>
       <p:sp>
         <p:nvSpPr>
-          <p:cNvPr id="27" name="Inhaltsplatzhalter 26">
+          <p:cNvPr id="4" name="footer_date">
+            <a:extLst>
+              <a:ext uri="{FF2B5EF4-FFF2-40B4-BE49-F238E27FC236}">
+                <a16:creationId xmlns:a16="http://schemas.microsoft.com/office/drawing/2014/main" id="{4091CEBF-0315-0376-AECC-72B522000048}"/>
+              </a:ext>
+            </a:extLst>
+          </p:cNvPr>
+          <p:cNvSpPr>
+            <a:spLocks noGrp="1"/>
+          </p:cNvSpPr>
+          <p:nvPr>
+            <p:ph type="dt" sz="half" idx="15"/>
+          </p:nvPr>
+        </p:nvSpPr>
+        <p:spPr/>
+        <p:txBody>
+          <a:bodyPr/>
+          <a:lstStyle/>
+          <a:p>
+            <a:pPr indent="-468000"/>
+            <a:fld id="{84284A58-3EB3-4F57-9112-3DEC02019146}" type="datetime1">
+              <a:rPr lang="de-DE" smtClean="0"/>
+              <a:t>22.06.2026</a:t>
+            </a:fld>
+            <a:endParaRPr lang="de-DE" dirty="0"/>
+          </a:p>
+        </p:txBody>
+      </p:sp>
+      <p:sp>
+        <p:nvSpPr>
+          <p:cNvPr id="6" name="footer_source">
+            <a:extLst>
+              <a:ext uri="{FF2B5EF4-FFF2-40B4-BE49-F238E27FC236}">
+                <a16:creationId xmlns:a16="http://schemas.microsoft.com/office/drawing/2014/main" id="{444FF8FF-43AA-977F-26BD-15CCF4FAB847}"/>
+              </a:ext>
+            </a:extLst>
+          </p:cNvPr>
+          <p:cNvSpPr>
+            <a:spLocks noGrp="1"/>
+          </p:cNvSpPr>
+          <p:nvPr>
+            <p:ph type="ftr" sz="quarter" idx="16"/>
+          </p:nvPr>
+        </p:nvSpPr>
+        <p:spPr/>
+        <p:txBody>
+          <a:bodyPr/>
+          <a:lstStyle/>
+          <a:p>
+            <a:pPr indent="-468000"/>
+            <a:r>
+              <a:rPr lang="de-DE" dirty="0"/>
+              <a:t>Würth Line Folienmaster</a:t>
+            </a:r>
+          </a:p>
+        </p:txBody>
+      </p:sp>
+      <p:sp>
+        <p:nvSpPr>
+          <p:cNvPr id="8" name="footer_slide_number">
+            <a:extLst>
+              <a:ext uri="{FF2B5EF4-FFF2-40B4-BE49-F238E27FC236}">
+                <a16:creationId xmlns:a16="http://schemas.microsoft.com/office/drawing/2014/main" id="{6D9836F3-62A2-3351-A51F-696852650367}"/>
+              </a:ext>
+            </a:extLst>
+          </p:cNvPr>
+          <p:cNvSpPr>
+            <a:spLocks noGrp="1"/>
+          </p:cNvSpPr>
+          <p:nvPr>
+            <p:ph type="sldNum" sz="quarter" idx="17"/>
+          </p:nvPr>
+        </p:nvSpPr>
+        <p:spPr/>
+        <p:txBody>
+          <a:bodyPr/>
+          <a:lstStyle/>
+          <a:p>
+            <a:fld id="{3CBD43C5-A65B-4791-8A9A-EB6408C246D1}" type="slidenum">
+              <a:rPr lang="de-DE" smtClean="0"/>
+              <a:pPr/>
+              <a:t>‹#›</a:t>
+            </a:fld>
+            <a:endParaRPr lang="de-DE" dirty="0"/>
+          </a:p>
+        </p:txBody>
+      </p:sp>
+      <p:sp>
+        <p:nvSpPr>
+          <p:cNvPr id="27" name="content">
             <a:extLst>
               <a:ext uri="{FF2B5EF4-FFF2-40B4-BE49-F238E27FC236}">
                 <a16:creationId xmlns:a16="http://schemas.microsoft.com/office/drawing/2014/main" id="{7D331E16-2D08-849C-B297-29B2C68773C5}"/>
@@ -4428,7 +4571,7 @@
       </p:sp>
       <p:sp>
         <p:nvSpPr>
-          <p:cNvPr id="12" name="Textplatzhalter 11">
+          <p:cNvPr id="12" name="section_label">
             <a:extLst>
               <a:ext uri="{FF2B5EF4-FFF2-40B4-BE49-F238E27FC236}">
                 <a16:creationId xmlns:a16="http://schemas.microsoft.com/office/drawing/2014/main" id="{E4BB559A-959F-E065-EED1-B99203950C30}"/>
@@ -4543,7 +4686,7 @@
       </p:sp>
       <p:sp>
         <p:nvSpPr>
-          <p:cNvPr id="16" name="Titel 15">
+          <p:cNvPr id="16" name="title">
             <a:extLst>
               <a:ext uri="{FF2B5EF4-FFF2-40B4-BE49-F238E27FC236}">
                 <a16:creationId xmlns:a16="http://schemas.microsoft.com/office/drawing/2014/main" id="{B6DFC255-7930-5C81-0D87-2A24C89824D6}"/>
@@ -4554,114 +4697,25 @@
             <a:spLocks noGrp="1"/>
           </p:cNvSpPr>
           <p:nvPr>
-            <p:ph type="title"/>
+            <p:ph type="title" hasCustomPrompt="1"/>
           </p:nvPr>
         </p:nvSpPr>
         <p:spPr bwMode="gray"/>
         <p:txBody>
-          <a:bodyPr vert="horz"/>
+          <a:bodyPr vert="horz" rIns="0"/>
           <a:lstStyle/>
           <a:p>
             <a:r>
               <a:rPr lang="de-DE" dirty="0"/>
               <a:t>Mastertitelformat bearbeiten</a:t>
             </a:r>
-          </a:p>
-        </p:txBody>
-      </p:sp>
-      <p:sp>
-        <p:nvSpPr>
-          <p:cNvPr id="4" name="Datumsplatzhalter 3">
-            <a:extLst>
-              <a:ext uri="{FF2B5EF4-FFF2-40B4-BE49-F238E27FC236}">
-                <a16:creationId xmlns:a16="http://schemas.microsoft.com/office/drawing/2014/main" id="{4091CEBF-0315-0376-AECC-72B522000048}"/>
-              </a:ext>
-            </a:extLst>
-          </p:cNvPr>
-          <p:cNvSpPr>
-            <a:spLocks noGrp="1"/>
-          </p:cNvSpPr>
-          <p:nvPr>
-            <p:ph type="dt" sz="half" idx="15"/>
-          </p:nvPr>
-        </p:nvSpPr>
-        <p:spPr/>
-        <p:txBody>
-          <a:bodyPr/>
-          <a:lstStyle/>
-          <a:p>
-            <a:pPr indent="-468000"/>
-            <a:fld id="{84284A58-3EB3-4F57-9112-3DEC02019146}" type="datetime1">
-              <a:rPr lang="de-DE" smtClean="0"/>
-              <a:t>21.06.2026</a:t>
-            </a:fld>
-            <a:endParaRPr lang="de-DE" dirty="0"/>
-          </a:p>
-        </p:txBody>
-      </p:sp>
-      <p:sp>
-        <p:nvSpPr>
-          <p:cNvPr id="6" name="Fußzeilenplatzhalter 5">
-            <a:extLst>
-              <a:ext uri="{FF2B5EF4-FFF2-40B4-BE49-F238E27FC236}">
-                <a16:creationId xmlns:a16="http://schemas.microsoft.com/office/drawing/2014/main" id="{444FF8FF-43AA-977F-26BD-15CCF4FAB847}"/>
-              </a:ext>
-            </a:extLst>
-          </p:cNvPr>
-          <p:cNvSpPr>
-            <a:spLocks noGrp="1"/>
-          </p:cNvSpPr>
-          <p:nvPr>
-            <p:ph type="ftr" sz="quarter" idx="16"/>
-          </p:nvPr>
-        </p:nvSpPr>
-        <p:spPr/>
-        <p:txBody>
-          <a:bodyPr/>
-          <a:lstStyle/>
-          <a:p>
-            <a:pPr indent="-468000"/>
-            <a:r>
-              <a:rPr lang="de-DE" dirty="0"/>
-              <a:t>Würth Line Folienmaster</a:t>
-            </a:r>
-          </a:p>
-        </p:txBody>
-      </p:sp>
-      <p:sp>
-        <p:nvSpPr>
-          <p:cNvPr id="8" name="Foliennummernplatzhalter 7">
-            <a:extLst>
-              <a:ext uri="{FF2B5EF4-FFF2-40B4-BE49-F238E27FC236}">
-                <a16:creationId xmlns:a16="http://schemas.microsoft.com/office/drawing/2014/main" id="{6D9836F3-62A2-3351-A51F-696852650367}"/>
-              </a:ext>
-            </a:extLst>
-          </p:cNvPr>
-          <p:cNvSpPr>
-            <a:spLocks noGrp="1"/>
-          </p:cNvSpPr>
-          <p:nvPr>
-            <p:ph type="sldNum" sz="quarter" idx="17"/>
-          </p:nvPr>
-        </p:nvSpPr>
-        <p:spPr/>
-        <p:txBody>
-          <a:bodyPr/>
-          <a:lstStyle/>
-          <a:p>
-            <a:fld id="{3CBD43C5-A65B-4791-8A9A-EB6408C246D1}" type="slidenum">
-              <a:rPr lang="de-DE" smtClean="0"/>
-              <a:pPr/>
-              <a:t>‹#›</a:t>
-            </a:fld>
-            <a:endParaRPr lang="de-DE" dirty="0"/>
           </a:p>
         </p:txBody>
       </p:sp>
     </p:spTree>
     <p:extLst>
       <p:ext uri="{BB962C8B-B14F-4D97-AF65-F5344CB8AC3E}">
-        <p14:creationId xmlns:p14="http://schemas.microsoft.com/office/powerpoint/2010/main" val="3768393544"/>
+        <p14:creationId xmlns:p14="http://schemas.microsoft.com/office/powerpoint/2010/main" val="1608891531"/>
       </p:ext>
     </p:extLst>
   </p:cSld>
@@ -4678,7 +4732,7 @@
 
 <file path=ppt/slideLayouts/slideLayout9.xml><?xml version="1.0" encoding="utf-8"?>
 <p:sldLayout xmlns:a="http://schemas.openxmlformats.org/drawingml/2006/main" xmlns:r="http://schemas.openxmlformats.org/officeDocument/2006/relationships" xmlns:p="http://schemas.openxmlformats.org/presentationml/2006/main" showMasterSp="0" preserve="1" userDrawn="1">
-  <p:cSld name="Agent 09 Closing">
+  <p:cSld name="agent_09_closing">
     <p:spTree>
       <p:nvGrpSpPr>
         <p:cNvPr id="1" name=""/>
@@ -4695,7 +4749,7 @@
       </p:grpSpPr>
       <p:pic>
         <p:nvPicPr>
-          <p:cNvPr id="5" name="Grafik 4" descr="Ein Bild, das Logo enthält.&#10;&#10;Automatisch generierte Beschreibung">
+          <p:cNvPr id="5" name="brand_logo" descr="Ein Bild, das Logo enthält.&#10;&#10;Automatisch generierte Beschreibung">
             <a:extLst>
               <a:ext uri="{FF2B5EF4-FFF2-40B4-BE49-F238E27FC236}">
                 <a16:creationId xmlns:a16="http://schemas.microsoft.com/office/drawing/2014/main" id="{2AFD3703-B3FC-AA0D-9674-79101F6B5B05}"/>
@@ -4846,292 +4900,9 @@
           </a:graphicData>
         </a:graphic>
       </p:graphicFrame>
-      <p:pic>
-        <p:nvPicPr>
-          <p:cNvPr id="7" name="Grafik 6" descr="Ein Bild, das Logo enthält.&#10;&#10;Automatisch generierte Beschreibung">
-            <a:extLst>
-              <a:ext uri="{FF2B5EF4-FFF2-40B4-BE49-F238E27FC236}">
-                <a16:creationId xmlns:a16="http://schemas.microsoft.com/office/drawing/2014/main" id="{F0847D62-A7EB-B4FC-8806-3207AB298524}"/>
-              </a:ext>
-            </a:extLst>
-          </p:cNvPr>
-          <p:cNvPicPr>
-            <a:picLocks noChangeAspect="1"/>
-          </p:cNvPicPr>
-          <p:nvPr userDrawn="1"/>
-        </p:nvPicPr>
-        <p:blipFill>
-          <a:blip r:embed="rId14">
-            <a:alphaModFix/>
-          </a:blip>
-          <a:stretch>
-            <a:fillRect/>
-          </a:stretch>
-        </p:blipFill>
-        <p:spPr bwMode="gray">
-          <a:xfrm>
-            <a:off x="7581433" y="253192"/>
-            <a:ext cx="1331197" cy="488587"/>
-          </a:xfrm>
-          <a:prstGeom prst="rect">
-            <a:avLst/>
-          </a:prstGeom>
-        </p:spPr>
-      </p:pic>
-      <p:sp>
-        <p:nvSpPr>
-          <p:cNvPr id="2" name="Titelplatzhalter 1">
-            <a:extLst>
-              <a:ext uri="{FF2B5EF4-FFF2-40B4-BE49-F238E27FC236}">
-                <a16:creationId xmlns:a16="http://schemas.microsoft.com/office/drawing/2014/main" id="{ED6F37AD-A388-ED69-053E-88262F83F1A6}"/>
-              </a:ext>
-            </a:extLst>
-          </p:cNvPr>
-          <p:cNvSpPr>
-            <a:spLocks noGrp="1"/>
-          </p:cNvSpPr>
-          <p:nvPr>
-            <p:ph type="title"/>
-          </p:nvPr>
-        </p:nvSpPr>
-        <p:spPr bwMode="gray">
-          <a:xfrm>
-            <a:off x="358775" y="338672"/>
-            <a:ext cx="7100425" cy="290849"/>
-          </a:xfrm>
-          <a:prstGeom prst="rect">
-            <a:avLst/>
-          </a:prstGeom>
-        </p:spPr>
-        <p:txBody>
-          <a:bodyPr vert="horz" lIns="0" tIns="0" rIns="0" bIns="0" rtlCol="0" anchor="t">
-            <a:noAutofit/>
-          </a:bodyPr>
-          <a:lstStyle/>
-          <a:p>
-            <a:r>
-              <a:rPr lang="de-DE" dirty="0"/>
-              <a:t>Mastertitelformat bearbeiten</a:t>
-            </a:r>
-          </a:p>
-        </p:txBody>
-      </p:sp>
-      <p:sp>
-        <p:nvSpPr>
-          <p:cNvPr id="3" name="Textplatzhalter 2">
-            <a:extLst>
-              <a:ext uri="{FF2B5EF4-FFF2-40B4-BE49-F238E27FC236}">
-                <a16:creationId xmlns:a16="http://schemas.microsoft.com/office/drawing/2014/main" id="{23EF8570-09D7-A87C-3F17-FD1D53B1676D}"/>
-              </a:ext>
-            </a:extLst>
-          </p:cNvPr>
-          <p:cNvSpPr>
-            <a:spLocks noGrp="1"/>
-          </p:cNvSpPr>
-          <p:nvPr>
-            <p:ph type="body" idx="1"/>
-          </p:nvPr>
-        </p:nvSpPr>
-        <p:spPr bwMode="gray">
-          <a:xfrm>
-            <a:off x="358775" y="1228182"/>
-            <a:ext cx="8426449" cy="3492000"/>
-          </a:xfrm>
-          <a:prstGeom prst="rect">
-            <a:avLst/>
-          </a:prstGeom>
-        </p:spPr>
-        <p:txBody>
-          <a:bodyPr vert="horz" lIns="0" tIns="0" rIns="0" bIns="0" rtlCol="0">
-            <a:noAutofit/>
-          </a:bodyPr>
-          <a:lstStyle/>
-          <a:p>
-            <a:pPr lvl="0"/>
-            <a:r>
-              <a:rPr lang="de-DE" dirty="0"/>
-              <a:t>Mastertextformat bearbeiten</a:t>
-            </a:r>
-          </a:p>
-          <a:p>
-            <a:pPr lvl="1"/>
-            <a:r>
-              <a:rPr lang="de-DE" dirty="0"/>
-              <a:t>Zweite Ebene</a:t>
-            </a:r>
-          </a:p>
-          <a:p>
-            <a:pPr lvl="2"/>
-            <a:r>
-              <a:rPr lang="de-DE" dirty="0"/>
-              <a:t>Dritte Ebene</a:t>
-            </a:r>
-          </a:p>
-          <a:p>
-            <a:pPr lvl="3"/>
-            <a:r>
-              <a:rPr lang="de-DE" dirty="0"/>
-              <a:t>Vierte Ebene</a:t>
-            </a:r>
-          </a:p>
-          <a:p>
-            <a:pPr lvl="4"/>
-            <a:r>
-              <a:rPr lang="de-DE" dirty="0"/>
-              <a:t>Fünfte Ebene</a:t>
-            </a:r>
-          </a:p>
-          <a:p>
-            <a:pPr lvl="5"/>
-            <a:r>
-              <a:rPr lang="de-DE" dirty="0"/>
-              <a:t>Sechste Ebene</a:t>
-            </a:r>
-          </a:p>
-          <a:p>
-            <a:pPr lvl="6"/>
-            <a:r>
-              <a:rPr lang="de-DE" dirty="0"/>
-              <a:t>Siebte Ebene</a:t>
-            </a:r>
-          </a:p>
-          <a:p>
-            <a:pPr lvl="7"/>
-            <a:r>
-              <a:rPr lang="de-DE" dirty="0"/>
-              <a:t>Achte Ebene</a:t>
-            </a:r>
-          </a:p>
-          <a:p>
-            <a:pPr lvl="8"/>
-            <a:r>
-              <a:rPr lang="de-DE" dirty="0"/>
-              <a:t>Neunte Ebene</a:t>
-            </a:r>
-          </a:p>
-        </p:txBody>
-      </p:sp>
-      <p:sp>
-        <p:nvSpPr>
-          <p:cNvPr id="6" name="Foliennummernplatzhalter 5">
-            <a:extLst>
-              <a:ext uri="{FF2B5EF4-FFF2-40B4-BE49-F238E27FC236}">
-                <a16:creationId xmlns:a16="http://schemas.microsoft.com/office/drawing/2014/main" id="{44BADFE5-9EF4-243C-D6AF-187767E4E1D1}"/>
-              </a:ext>
-            </a:extLst>
-          </p:cNvPr>
-          <p:cNvSpPr>
-            <a:spLocks noGrp="1"/>
-          </p:cNvSpPr>
-          <p:nvPr>
-            <p:ph type="sldNum" sz="quarter" idx="4"/>
-          </p:nvPr>
-        </p:nvSpPr>
-        <p:spPr bwMode="gray">
-          <a:xfrm>
-            <a:off x="358775" y="4920303"/>
-            <a:ext cx="204257" cy="107722"/>
-          </a:xfrm>
-          <a:prstGeom prst="rect">
-            <a:avLst/>
-          </a:prstGeom>
-        </p:spPr>
-        <p:txBody>
-          <a:bodyPr vert="horz" lIns="0" tIns="0" rIns="0" bIns="0" rtlCol="0" anchor="t">
-            <a:noAutofit/>
-          </a:bodyPr>
-          <a:lstStyle>
-            <a:lvl1pPr algn="l">
-              <a:defRPr sz="700">
-                <a:solidFill>
-                  <a:schemeClr val="tx1"/>
-                </a:solidFill>
-                <a:latin typeface="+mn-lt"/>
-              </a:defRPr>
-            </a:lvl1pPr>
-          </a:lstStyle>
-          <a:p>
-            <a:fld id="{3CBD43C5-A65B-4791-8A9A-EB6408C246D1}" type="slidenum">
-              <a:rPr lang="de-DE" smtClean="0"/>
-              <a:pPr/>
-              <a:t>‹#›</a:t>
-            </a:fld>
-            <a:endParaRPr lang="de-DE" dirty="0"/>
-          </a:p>
-        </p:txBody>
-      </p:sp>
-      <p:sp>
-        <p:nvSpPr>
-          <p:cNvPr id="11" name="Fußzeilenplatzhalter 10">
-            <a:extLst>
-              <a:ext uri="{FF2B5EF4-FFF2-40B4-BE49-F238E27FC236}">
-                <a16:creationId xmlns:a16="http://schemas.microsoft.com/office/drawing/2014/main" id="{FFBAADEE-AF24-CB14-FE0D-DB24AF94888E}"/>
-              </a:ext>
-            </a:extLst>
-          </p:cNvPr>
-          <p:cNvSpPr>
-            <a:spLocks noGrp="1"/>
-          </p:cNvSpPr>
-          <p:nvPr>
-            <p:ph type="ftr" sz="quarter" idx="3"/>
-          </p:nvPr>
-        </p:nvSpPr>
-        <p:spPr bwMode="gray">
-          <a:xfrm>
-            <a:off x="618275" y="4920303"/>
-            <a:ext cx="4828311" cy="107722"/>
-          </a:xfrm>
-          <a:prstGeom prst="rect">
-            <a:avLst/>
-          </a:prstGeom>
-        </p:spPr>
-        <p:txBody>
-          <a:bodyPr vert="horz" lIns="0" tIns="0" rIns="0" bIns="0" rtlCol="0" anchor="t" anchorCtr="0"/>
-          <a:lstStyle>
-            <a:lvl1pPr algn="l">
-              <a:defRPr sz="700" cap="all" baseline="0">
-                <a:solidFill>
-                  <a:schemeClr val="tx1"/>
-                </a:solidFill>
-              </a:defRPr>
-            </a:lvl1pPr>
-            <a:lvl2pPr>
-              <a:defRPr sz="700" cap="all" baseline="0"/>
-            </a:lvl2pPr>
-            <a:lvl3pPr>
-              <a:defRPr sz="700" cap="all" baseline="0"/>
-            </a:lvl3pPr>
-            <a:lvl4pPr marL="0">
-              <a:defRPr sz="700" cap="all" baseline="0"/>
-            </a:lvl4pPr>
-            <a:lvl5pPr marL="0">
-              <a:defRPr sz="700" cap="all" baseline="0"/>
-            </a:lvl5pPr>
-            <a:lvl6pPr marL="0">
-              <a:defRPr sz="700" cap="all" baseline="0"/>
-            </a:lvl6pPr>
-            <a:lvl7pPr marL="0">
-              <a:defRPr sz="700" cap="all" baseline="0"/>
-            </a:lvl7pPr>
-            <a:lvl8pPr marL="0">
-              <a:defRPr sz="700" cap="all" baseline="0"/>
-            </a:lvl8pPr>
-            <a:lvl9pPr marL="0">
-              <a:defRPr sz="700" cap="all" baseline="0"/>
-            </a:lvl9pPr>
-          </a:lstStyle>
-          <a:p>
-            <a:pPr indent="-468000"/>
-            <a:r>
-              <a:rPr lang="de-DE" dirty="0"/>
-              <a:t>Würth Line Folienmaster</a:t>
-            </a:r>
-          </a:p>
-        </p:txBody>
-      </p:sp>
-      <p:sp>
-        <p:nvSpPr>
-          <p:cNvPr id="4" name="Datumsplatzhalter 3">
+      <p:sp>
+        <p:nvSpPr>
+          <p:cNvPr id="4" name="footer_date">
             <a:extLst>
               <a:ext uri="{FF2B5EF4-FFF2-40B4-BE49-F238E27FC236}">
                 <a16:creationId xmlns:a16="http://schemas.microsoft.com/office/drawing/2014/main" id="{5F882E47-52BC-4F68-561B-15653AB5181F}"/>
@@ -5165,7 +4936,7 @@
             <a:pPr indent="-468000"/>
             <a:fld id="{84284A58-3EB3-4F57-9112-3DEC02019146}" type="datetime1">
               <a:rPr lang="de-DE" smtClean="0"/>
-              <a:t>21.06.2026</a:t>
+              <a:t>22.06.2026</a:t>
             </a:fld>
             <a:endParaRPr lang="de-DE" dirty="0"/>
           </a:p>
@@ -5173,7 +4944,7 @@
       </p:sp>
       <p:sp>
         <p:nvSpPr>
-          <p:cNvPr id="5" name="Textplatzhalter 19">
+          <p:cNvPr id="5" name="footer_copyright">
             <a:extLst>
               <a:ext uri="{FF2B5EF4-FFF2-40B4-BE49-F238E27FC236}">
                 <a16:creationId xmlns:a16="http://schemas.microsoft.com/office/drawing/2014/main" id="{A5458361-860D-10A6-C9E1-0FECDEE13589}"/>
@@ -5432,6 +5203,289 @@
           </a:p>
         </p:txBody>
       </p:sp>
+      <p:sp>
+        <p:nvSpPr>
+          <p:cNvPr id="11" name="footer_source">
+            <a:extLst>
+              <a:ext uri="{FF2B5EF4-FFF2-40B4-BE49-F238E27FC236}">
+                <a16:creationId xmlns:a16="http://schemas.microsoft.com/office/drawing/2014/main" id="{FFBAADEE-AF24-CB14-FE0D-DB24AF94888E}"/>
+              </a:ext>
+            </a:extLst>
+          </p:cNvPr>
+          <p:cNvSpPr>
+            <a:spLocks noGrp="1"/>
+          </p:cNvSpPr>
+          <p:nvPr>
+            <p:ph type="ftr" sz="quarter" idx="3"/>
+          </p:nvPr>
+        </p:nvSpPr>
+        <p:spPr bwMode="gray">
+          <a:xfrm>
+            <a:off x="618275" y="4920303"/>
+            <a:ext cx="4828311" cy="107722"/>
+          </a:xfrm>
+          <a:prstGeom prst="rect">
+            <a:avLst/>
+          </a:prstGeom>
+        </p:spPr>
+        <p:txBody>
+          <a:bodyPr vert="horz" lIns="0" tIns="0" rIns="0" bIns="0" rtlCol="0" anchor="t" anchorCtr="0"/>
+          <a:lstStyle>
+            <a:lvl1pPr algn="l">
+              <a:defRPr sz="700" cap="all" baseline="0">
+                <a:solidFill>
+                  <a:schemeClr val="tx1"/>
+                </a:solidFill>
+              </a:defRPr>
+            </a:lvl1pPr>
+            <a:lvl2pPr>
+              <a:defRPr sz="700" cap="all" baseline="0"/>
+            </a:lvl2pPr>
+            <a:lvl3pPr>
+              <a:defRPr sz="700" cap="all" baseline="0"/>
+            </a:lvl3pPr>
+            <a:lvl4pPr marL="0">
+              <a:defRPr sz="700" cap="all" baseline="0"/>
+            </a:lvl4pPr>
+            <a:lvl5pPr marL="0">
+              <a:defRPr sz="700" cap="all" baseline="0"/>
+            </a:lvl5pPr>
+            <a:lvl6pPr marL="0">
+              <a:defRPr sz="700" cap="all" baseline="0"/>
+            </a:lvl6pPr>
+            <a:lvl7pPr marL="0">
+              <a:defRPr sz="700" cap="all" baseline="0"/>
+            </a:lvl7pPr>
+            <a:lvl8pPr marL="0">
+              <a:defRPr sz="700" cap="all" baseline="0"/>
+            </a:lvl8pPr>
+            <a:lvl9pPr marL="0">
+              <a:defRPr sz="700" cap="all" baseline="0"/>
+            </a:lvl9pPr>
+          </a:lstStyle>
+          <a:p>
+            <a:pPr indent="-468000"/>
+            <a:r>
+              <a:rPr lang="de-DE" dirty="0"/>
+              <a:t>Würth Line Folienmaster</a:t>
+            </a:r>
+          </a:p>
+        </p:txBody>
+      </p:sp>
+      <p:sp>
+        <p:nvSpPr>
+          <p:cNvPr id="6" name="footer_slide_number">
+            <a:extLst>
+              <a:ext uri="{FF2B5EF4-FFF2-40B4-BE49-F238E27FC236}">
+                <a16:creationId xmlns:a16="http://schemas.microsoft.com/office/drawing/2014/main" id="{44BADFE5-9EF4-243C-D6AF-187767E4E1D1}"/>
+              </a:ext>
+            </a:extLst>
+          </p:cNvPr>
+          <p:cNvSpPr>
+            <a:spLocks noGrp="1"/>
+          </p:cNvSpPr>
+          <p:nvPr>
+            <p:ph type="sldNum" sz="quarter" idx="4"/>
+          </p:nvPr>
+        </p:nvSpPr>
+        <p:spPr bwMode="gray">
+          <a:xfrm>
+            <a:off x="358775" y="4920303"/>
+            <a:ext cx="204257" cy="107722"/>
+          </a:xfrm>
+          <a:prstGeom prst="rect">
+            <a:avLst/>
+          </a:prstGeom>
+        </p:spPr>
+        <p:txBody>
+          <a:bodyPr vert="horz" lIns="0" tIns="0" rIns="0" bIns="0" rtlCol="0" anchor="t">
+            <a:noAutofit/>
+          </a:bodyPr>
+          <a:lstStyle>
+            <a:lvl1pPr algn="l">
+              <a:defRPr sz="700">
+                <a:solidFill>
+                  <a:schemeClr val="tx1"/>
+                </a:solidFill>
+                <a:latin typeface="+mn-lt"/>
+              </a:defRPr>
+            </a:lvl1pPr>
+          </a:lstStyle>
+          <a:p>
+            <a:fld id="{3CBD43C5-A65B-4791-8A9A-EB6408C246D1}" type="slidenum">
+              <a:rPr lang="de-DE" smtClean="0"/>
+              <a:pPr/>
+              <a:t>‹#›</a:t>
+            </a:fld>
+            <a:endParaRPr lang="de-DE" dirty="0"/>
+          </a:p>
+        </p:txBody>
+      </p:sp>
+      <p:sp>
+        <p:nvSpPr>
+          <p:cNvPr id="3" name="body">
+            <a:extLst>
+              <a:ext uri="{FF2B5EF4-FFF2-40B4-BE49-F238E27FC236}">
+                <a16:creationId xmlns:a16="http://schemas.microsoft.com/office/drawing/2014/main" id="{23EF8570-09D7-A87C-3F17-FD1D53B1676D}"/>
+              </a:ext>
+            </a:extLst>
+          </p:cNvPr>
+          <p:cNvSpPr>
+            <a:spLocks noGrp="1"/>
+          </p:cNvSpPr>
+          <p:nvPr>
+            <p:ph type="body" idx="1"/>
+          </p:nvPr>
+        </p:nvSpPr>
+        <p:spPr bwMode="gray">
+          <a:xfrm>
+            <a:off x="358775" y="1228182"/>
+            <a:ext cx="8426449" cy="3492000"/>
+          </a:xfrm>
+          <a:prstGeom prst="rect">
+            <a:avLst/>
+          </a:prstGeom>
+        </p:spPr>
+        <p:txBody>
+          <a:bodyPr vert="horz" lIns="0" tIns="0" rIns="0" bIns="0" rtlCol="0">
+            <a:noAutofit/>
+          </a:bodyPr>
+          <a:lstStyle/>
+          <a:p>
+            <a:pPr lvl="0"/>
+            <a:r>
+              <a:rPr lang="de-DE" dirty="0"/>
+              <a:t>Mastertextformat bearbeiten</a:t>
+            </a:r>
+          </a:p>
+          <a:p>
+            <a:pPr lvl="1"/>
+            <a:r>
+              <a:rPr lang="de-DE" dirty="0"/>
+              <a:t>Zweite Ebene</a:t>
+            </a:r>
+          </a:p>
+          <a:p>
+            <a:pPr lvl="2"/>
+            <a:r>
+              <a:rPr lang="de-DE" dirty="0"/>
+              <a:t>Dritte Ebene</a:t>
+            </a:r>
+          </a:p>
+          <a:p>
+            <a:pPr lvl="3"/>
+            <a:r>
+              <a:rPr lang="de-DE" dirty="0"/>
+              <a:t>Vierte Ebene</a:t>
+            </a:r>
+          </a:p>
+          <a:p>
+            <a:pPr lvl="4"/>
+            <a:r>
+              <a:rPr lang="de-DE" dirty="0"/>
+              <a:t>Fünfte Ebene</a:t>
+            </a:r>
+          </a:p>
+          <a:p>
+            <a:pPr lvl="5"/>
+            <a:r>
+              <a:rPr lang="de-DE" dirty="0"/>
+              <a:t>Sechste Ebene</a:t>
+            </a:r>
+          </a:p>
+          <a:p>
+            <a:pPr lvl="6"/>
+            <a:r>
+              <a:rPr lang="de-DE" dirty="0"/>
+              <a:t>Siebte Ebene</a:t>
+            </a:r>
+          </a:p>
+          <a:p>
+            <a:pPr lvl="7"/>
+            <a:r>
+              <a:rPr lang="de-DE" dirty="0"/>
+              <a:t>Achte Ebene</a:t>
+            </a:r>
+          </a:p>
+          <a:p>
+            <a:pPr lvl="8"/>
+            <a:r>
+              <a:rPr lang="de-DE" dirty="0"/>
+              <a:t>Neunte Ebene</a:t>
+            </a:r>
+          </a:p>
+        </p:txBody>
+      </p:sp>
+      <p:pic>
+        <p:nvPicPr>
+          <p:cNvPr id="7" name="brand_logo" descr="Ein Bild, das Logo enthält.&#10;&#10;Automatisch generierte Beschreibung">
+            <a:extLst>
+              <a:ext uri="{FF2B5EF4-FFF2-40B4-BE49-F238E27FC236}">
+                <a16:creationId xmlns:a16="http://schemas.microsoft.com/office/drawing/2014/main" id="{F0847D62-A7EB-B4FC-8806-3207AB298524}"/>
+              </a:ext>
+            </a:extLst>
+          </p:cNvPr>
+          <p:cNvPicPr>
+            <a:picLocks noChangeAspect="1"/>
+          </p:cNvPicPr>
+          <p:nvPr userDrawn="1"/>
+        </p:nvPicPr>
+        <p:blipFill>
+          <a:blip r:embed="rId14">
+            <a:alphaModFix/>
+          </a:blip>
+          <a:stretch>
+            <a:fillRect/>
+          </a:stretch>
+        </p:blipFill>
+        <p:spPr bwMode="gray">
+          <a:xfrm>
+            <a:off x="7581433" y="253192"/>
+            <a:ext cx="1331197" cy="488587"/>
+          </a:xfrm>
+          <a:prstGeom prst="rect">
+            <a:avLst/>
+          </a:prstGeom>
+        </p:spPr>
+      </p:pic>
+      <p:sp>
+        <p:nvSpPr>
+          <p:cNvPr id="2" name="title">
+            <a:extLst>
+              <a:ext uri="{FF2B5EF4-FFF2-40B4-BE49-F238E27FC236}">
+                <a16:creationId xmlns:a16="http://schemas.microsoft.com/office/drawing/2014/main" id="{ED6F37AD-A388-ED69-053E-88262F83F1A6}"/>
+              </a:ext>
+            </a:extLst>
+          </p:cNvPr>
+          <p:cNvSpPr>
+            <a:spLocks noGrp="1"/>
+          </p:cNvSpPr>
+          <p:nvPr>
+            <p:ph type="title"/>
+          </p:nvPr>
+        </p:nvSpPr>
+        <p:spPr bwMode="gray">
+          <a:xfrm>
+            <a:off x="358775" y="338672"/>
+            <a:ext cx="7100425" cy="290849"/>
+          </a:xfrm>
+          <a:prstGeom prst="rect">
+            <a:avLst/>
+          </a:prstGeom>
+        </p:spPr>
+        <p:txBody>
+          <a:bodyPr vert="horz" lIns="0" tIns="0" rIns="0" bIns="0" rtlCol="0" anchor="t">
+            <a:noAutofit/>
+          </a:bodyPr>
+          <a:lstStyle/>
+          <a:p>
+            <a:r>
+              <a:rPr lang="de-DE" dirty="0"/>
+              <a:t>Mastertitelformat bearbeiten</a:t>
+            </a:r>
+          </a:p>
+        </p:txBody>
+      </p:sp>
     </p:spTree>
     <p:extLst>
       <p:ext uri="{BB962C8B-B14F-4D97-AF65-F5344CB8AC3E}">
@@ -5445,10 +5499,10 @@
     <p:sldLayoutId id="2147483685" r:id="rId2"/>
     <p:sldLayoutId id="2147483724" r:id="rId3"/>
     <p:sldLayoutId id="2147483723" r:id="rId4"/>
-    <p:sldLayoutId id="2147483734" r:id="rId5"/>
+    <p:sldLayoutId id="2147483736" r:id="rId5"/>
     <p:sldLayoutId id="2147483687" r:id="rId6"/>
-    <p:sldLayoutId id="2147483733" r:id="rId7"/>
-    <p:sldLayoutId id="2147483735" r:id="rId8"/>
+    <p:sldLayoutId id="2147483737" r:id="rId7"/>
+    <p:sldLayoutId id="2147483738" r:id="rId8"/>
     <p:sldLayoutId id="2147483692" r:id="rId9"/>
   </p:sldLayoutIdLst>
   <p:hf hdr="0"/>

</xml_diff>

<commit_message>
fix(ppt): improve planner logging and footer rendering
</commit_message>
<xml_diff>
--- a/assets/templates/PPT_Vorlage_Wuerth.pptx
+++ b/assets/templates/PPT_Vorlage_Wuerth.pptx
@@ -1075,10 +1075,12 @@
           </a:xfrm>
         </p:spPr>
         <p:txBody>
-          <a:bodyPr lIns="0" anchor="t"/>
+          <a:bodyPr vert="horz" lIns="0" tIns="0" rIns="0" bIns="0" rtlCol="0" anchor="t">
+            <a:noAutofit/>
+          </a:bodyPr>
           <a:lstStyle>
             <a:lvl1pPr>
-              <a:defRPr sz="1600">
+              <a:defRPr lang="de-DE" sz="1600" dirty="0">
                 <a:solidFill>
                   <a:schemeClr val="bg1"/>
                 </a:solidFill>

</xml_diff>